<commit_message>
Demo interactiva en vivo (caja de texto + botones ES/EN), notas del orador en las 27 laminas y auditoria final en verde
</commit_message>
<xml_diff>
--- a/presentacion/Presentacion_Trabajo_Final_PLN_CarlosPerez.pptx
+++ b/presentacion/Presentacion_Trabajo_Final_PLN_CarlosPerez.pptx
@@ -131,6 +131,2246 @@
     </a:lvl9pPr>
   </p:defaultTextStyle>
 </p:presentation>
+</file>
+
+<file path=ppt/notesMasters/notesMaster1.xml><?xml version="1.0" encoding="utf-8"?>
+<p:notesMaster xmlns:a="http://schemas.openxmlformats.org/drawingml/2006/main" xmlns:p="http://schemas.openxmlformats.org/presentationml/2006/main" xmlns:r="http://schemas.openxmlformats.org/officeDocument/2006/relationships">
+  <p:cSld>
+    <p:bg>
+      <p:bgRef idx="1001">
+        <a:schemeClr val="bg1"/>
+      </p:bgRef>
+    </p:bg>
+    <p:spTree>
+      <p:nvGrpSpPr>
+        <p:cNvPr id="1" name=""/>
+        <p:cNvGrpSpPr/>
+        <p:nvPr/>
+      </p:nvGrpSpPr>
+      <p:grpSpPr>
+        <a:xfrm>
+          <a:off x="0" y="0"/>
+          <a:ext cx="0" cy="0"/>
+          <a:chOff x="0" y="0"/>
+          <a:chExt cx="0" cy="0"/>
+        </a:xfrm>
+      </p:grpSpPr>
+      <p:sp>
+        <p:nvSpPr>
+          <p:cNvPr id="2" name="Header Placeholder 1"/>
+          <p:cNvSpPr>
+            <a:spLocks noGrp="1"/>
+          </p:cNvSpPr>
+          <p:nvPr>
+            <p:ph type="hdr" sz="quarter"/>
+          </p:nvPr>
+        </p:nvSpPr>
+        <p:spPr>
+          <a:xfrm>
+            <a:off x="0" y="0"/>
+            <a:ext cx="2971800" cy="457200"/>
+          </a:xfrm>
+          <a:prstGeom prst="rect">
+            <a:avLst/>
+          </a:prstGeom>
+        </p:spPr>
+        <p:txBody>
+          <a:bodyPr vert="horz" lIns="91440" tIns="45720" rIns="91440" bIns="45720" rtlCol="0"/>
+          <a:lstStyle>
+            <a:lvl1pPr algn="l">
+              <a:defRPr sz="1200"/>
+            </a:lvl1pPr>
+          </a:lstStyle>
+          <a:p>
+            <a:endParaRPr lang="en-US"/>
+          </a:p>
+        </p:txBody>
+      </p:sp>
+      <p:sp>
+        <p:nvSpPr>
+          <p:cNvPr id="3" name="Date Placeholder 2"/>
+          <p:cNvSpPr>
+            <a:spLocks noGrp="1"/>
+          </p:cNvSpPr>
+          <p:nvPr>
+            <p:ph type="dt" idx="1"/>
+          </p:nvPr>
+        </p:nvSpPr>
+        <p:spPr>
+          <a:xfrm>
+            <a:off x="3884613" y="0"/>
+            <a:ext cx="2971800" cy="457200"/>
+          </a:xfrm>
+          <a:prstGeom prst="rect">
+            <a:avLst/>
+          </a:prstGeom>
+        </p:spPr>
+        <p:txBody>
+          <a:bodyPr vert="horz" lIns="91440" tIns="45720" rIns="91440" bIns="45720" rtlCol="0"/>
+          <a:lstStyle>
+            <a:lvl1pPr algn="r">
+              <a:defRPr sz="1200"/>
+            </a:lvl1pPr>
+          </a:lstStyle>
+          <a:p>
+            <a:fld id="{0F89C1C7-3DCD-1040-A9CF-14679D8B5DDD}" type="datetimeFigureOut">
+              <a:rPr lang="en-US" smtClean="0"/>
+              <a:t>10/17/16</a:t>
+            </a:fld>
+            <a:endParaRPr lang="en-US"/>
+          </a:p>
+        </p:txBody>
+      </p:sp>
+      <p:sp>
+        <p:nvSpPr>
+          <p:cNvPr id="4" name="Slide Image Placeholder 3"/>
+          <p:cNvSpPr>
+            <a:spLocks noGrp="1" noRot="1" noChangeAspect="1"/>
+          </p:cNvSpPr>
+          <p:nvPr>
+            <p:ph type="sldImg" idx="2"/>
+          </p:nvPr>
+        </p:nvSpPr>
+        <p:spPr>
+          <a:xfrm>
+            <a:off x="1143000" y="685800"/>
+            <a:ext cx="4572000" cy="3429000"/>
+          </a:xfrm>
+          <a:prstGeom prst="rect">
+            <a:avLst/>
+          </a:prstGeom>
+          <a:noFill/>
+          <a:ln w="12700">
+            <a:solidFill>
+              <a:prstClr val="black"/>
+            </a:solidFill>
+          </a:ln>
+        </p:spPr>
+        <p:txBody>
+          <a:bodyPr vert="horz" lIns="91440" tIns="45720" rIns="91440" bIns="45720" rtlCol="0" anchor="ctr"/>
+          <a:lstStyle/>
+          <a:p>
+            <a:endParaRPr lang="en-US"/>
+          </a:p>
+        </p:txBody>
+      </p:sp>
+      <p:sp>
+        <p:nvSpPr>
+          <p:cNvPr id="5" name="Notes Placeholder 4"/>
+          <p:cNvSpPr>
+            <a:spLocks noGrp="1"/>
+          </p:cNvSpPr>
+          <p:nvPr>
+            <p:ph type="body" sz="quarter" idx="3"/>
+          </p:nvPr>
+        </p:nvSpPr>
+        <p:spPr>
+          <a:xfrm>
+            <a:off x="685800" y="4343400"/>
+            <a:ext cx="5486400" cy="4114800"/>
+          </a:xfrm>
+          <a:prstGeom prst="rect">
+            <a:avLst/>
+          </a:prstGeom>
+        </p:spPr>
+        <p:txBody>
+          <a:bodyPr vert="horz" lIns="91440" tIns="45720" rIns="91440" bIns="45720" rtlCol="0"/>
+          <a:lstStyle/>
+          <a:p>
+            <a:pPr lvl="0"/>
+            <a:r>
+              <a:rPr lang="en-US" smtClean="0"/>
+              <a:t>Click to edit Master text styles</a:t>
+            </a:r>
+          </a:p>
+          <a:p>
+            <a:pPr lvl="1"/>
+            <a:r>
+              <a:rPr lang="en-US" smtClean="0"/>
+              <a:t>Second level</a:t>
+            </a:r>
+          </a:p>
+          <a:p>
+            <a:pPr lvl="2"/>
+            <a:r>
+              <a:rPr lang="en-US" smtClean="0"/>
+              <a:t>Third level</a:t>
+            </a:r>
+          </a:p>
+          <a:p>
+            <a:pPr lvl="3"/>
+            <a:r>
+              <a:rPr lang="en-US" smtClean="0"/>
+              <a:t>Fourth level</a:t>
+            </a:r>
+          </a:p>
+          <a:p>
+            <a:pPr lvl="4"/>
+            <a:r>
+              <a:rPr lang="en-US" smtClean="0"/>
+              <a:t>Fifth level</a:t>
+            </a:r>
+            <a:endParaRPr lang="en-US"/>
+          </a:p>
+        </p:txBody>
+      </p:sp>
+      <p:sp>
+        <p:nvSpPr>
+          <p:cNvPr id="6" name="Footer Placeholder 5"/>
+          <p:cNvSpPr>
+            <a:spLocks noGrp="1"/>
+          </p:cNvSpPr>
+          <p:nvPr>
+            <p:ph type="ftr" sz="quarter" idx="4"/>
+          </p:nvPr>
+        </p:nvSpPr>
+        <p:spPr>
+          <a:xfrm>
+            <a:off x="0" y="8685213"/>
+            <a:ext cx="2971800" cy="457200"/>
+          </a:xfrm>
+          <a:prstGeom prst="rect">
+            <a:avLst/>
+          </a:prstGeom>
+        </p:spPr>
+        <p:txBody>
+          <a:bodyPr vert="horz" lIns="91440" tIns="45720" rIns="91440" bIns="45720" rtlCol="0" anchor="b"/>
+          <a:lstStyle>
+            <a:lvl1pPr algn="l">
+              <a:defRPr sz="1200"/>
+            </a:lvl1pPr>
+          </a:lstStyle>
+          <a:p>
+            <a:endParaRPr lang="en-US"/>
+          </a:p>
+        </p:txBody>
+      </p:sp>
+      <p:sp>
+        <p:nvSpPr>
+          <p:cNvPr id="7" name="Slide Number Placeholder 6"/>
+          <p:cNvSpPr>
+            <a:spLocks noGrp="1"/>
+          </p:cNvSpPr>
+          <p:nvPr>
+            <p:ph type="sldNum" sz="quarter" idx="5"/>
+          </p:nvPr>
+        </p:nvSpPr>
+        <p:spPr>
+          <a:xfrm>
+            <a:off x="3884613" y="8685213"/>
+            <a:ext cx="2971800" cy="457200"/>
+          </a:xfrm>
+          <a:prstGeom prst="rect">
+            <a:avLst/>
+          </a:prstGeom>
+        </p:spPr>
+        <p:txBody>
+          <a:bodyPr vert="horz" lIns="91440" tIns="45720" rIns="91440" bIns="45720" rtlCol="0" anchor="b"/>
+          <a:lstStyle>
+            <a:lvl1pPr algn="r">
+              <a:defRPr sz="1200"/>
+            </a:lvl1pPr>
+          </a:lstStyle>
+          <a:p>
+            <a:fld id="{BB5E49A5-4136-284D-997B-48E1D791AD67}" type="slidenum">
+              <a:rPr lang="en-US" smtClean="0"/>
+              <a:t>‹#›</a:t>
+            </a:fld>
+            <a:endParaRPr lang="en-US"/>
+          </a:p>
+        </p:txBody>
+      </p:sp>
+    </p:spTree>
+    <p:extLst>
+      <p:ext uri="{BB962C8B-B14F-4D97-AF65-F5344CB8AC3E}">
+        <p14:creationId xmlns:p14="http://schemas.microsoft.com/office/powerpoint/2010/main" val="2623252185"/>
+      </p:ext>
+    </p:extLst>
+  </p:cSld>
+  <p:clrMap bg1="lt1" tx1="dk1" bg2="lt2" tx2="dk2" accent1="accent1" accent2="accent2" accent3="accent3" accent4="accent4" accent5="accent5" accent6="accent6" hlink="hlink" folHlink="folHlink"/>
+  <p:notesStyle>
+    <a:lvl1pPr marL="0" algn="l" defTabSz="457200" rtl="0" eaLnBrk="1" latinLnBrk="0" hangingPunct="1">
+      <a:defRPr sz="1200" kern="1200">
+        <a:solidFill>
+          <a:schemeClr val="tx1"/>
+        </a:solidFill>
+        <a:latin typeface="+mn-lt"/>
+        <a:ea typeface="+mn-ea"/>
+        <a:cs typeface="+mn-cs"/>
+      </a:defRPr>
+    </a:lvl1pPr>
+    <a:lvl2pPr marL="457200" algn="l" defTabSz="457200" rtl="0" eaLnBrk="1" latinLnBrk="0" hangingPunct="1">
+      <a:defRPr sz="1200" kern="1200">
+        <a:solidFill>
+          <a:schemeClr val="tx1"/>
+        </a:solidFill>
+        <a:latin typeface="+mn-lt"/>
+        <a:ea typeface="+mn-ea"/>
+        <a:cs typeface="+mn-cs"/>
+      </a:defRPr>
+    </a:lvl2pPr>
+    <a:lvl3pPr marL="914400" algn="l" defTabSz="457200" rtl="0" eaLnBrk="1" latinLnBrk="0" hangingPunct="1">
+      <a:defRPr sz="1200" kern="1200">
+        <a:solidFill>
+          <a:schemeClr val="tx1"/>
+        </a:solidFill>
+        <a:latin typeface="+mn-lt"/>
+        <a:ea typeface="+mn-ea"/>
+        <a:cs typeface="+mn-cs"/>
+      </a:defRPr>
+    </a:lvl3pPr>
+    <a:lvl4pPr marL="1371600" algn="l" defTabSz="457200" rtl="0" eaLnBrk="1" latinLnBrk="0" hangingPunct="1">
+      <a:defRPr sz="1200" kern="1200">
+        <a:solidFill>
+          <a:schemeClr val="tx1"/>
+        </a:solidFill>
+        <a:latin typeface="+mn-lt"/>
+        <a:ea typeface="+mn-ea"/>
+        <a:cs typeface="+mn-cs"/>
+      </a:defRPr>
+    </a:lvl4pPr>
+    <a:lvl5pPr marL="1828800" algn="l" defTabSz="457200" rtl="0" eaLnBrk="1" latinLnBrk="0" hangingPunct="1">
+      <a:defRPr sz="1200" kern="1200">
+        <a:solidFill>
+          <a:schemeClr val="tx1"/>
+        </a:solidFill>
+        <a:latin typeface="+mn-lt"/>
+        <a:ea typeface="+mn-ea"/>
+        <a:cs typeface="+mn-cs"/>
+      </a:defRPr>
+    </a:lvl5pPr>
+    <a:lvl6pPr marL="2286000" algn="l" defTabSz="457200" rtl="0" eaLnBrk="1" latinLnBrk="0" hangingPunct="1">
+      <a:defRPr sz="1200" kern="1200">
+        <a:solidFill>
+          <a:schemeClr val="tx1"/>
+        </a:solidFill>
+        <a:latin typeface="+mn-lt"/>
+        <a:ea typeface="+mn-ea"/>
+        <a:cs typeface="+mn-cs"/>
+      </a:defRPr>
+    </a:lvl6pPr>
+    <a:lvl7pPr marL="2743200" algn="l" defTabSz="457200" rtl="0" eaLnBrk="1" latinLnBrk="0" hangingPunct="1">
+      <a:defRPr sz="1200" kern="1200">
+        <a:solidFill>
+          <a:schemeClr val="tx1"/>
+        </a:solidFill>
+        <a:latin typeface="+mn-lt"/>
+        <a:ea typeface="+mn-ea"/>
+        <a:cs typeface="+mn-cs"/>
+      </a:defRPr>
+    </a:lvl7pPr>
+    <a:lvl8pPr marL="3200400" algn="l" defTabSz="457200" rtl="0" eaLnBrk="1" latinLnBrk="0" hangingPunct="1">
+      <a:defRPr sz="1200" kern="1200">
+        <a:solidFill>
+          <a:schemeClr val="tx1"/>
+        </a:solidFill>
+        <a:latin typeface="+mn-lt"/>
+        <a:ea typeface="+mn-ea"/>
+        <a:cs typeface="+mn-cs"/>
+      </a:defRPr>
+    </a:lvl8pPr>
+    <a:lvl9pPr marL="3657600" algn="l" defTabSz="457200" rtl="0" eaLnBrk="1" latinLnBrk="0" hangingPunct="1">
+      <a:defRPr sz="1200" kern="1200">
+        <a:solidFill>
+          <a:schemeClr val="tx1"/>
+        </a:solidFill>
+        <a:latin typeface="+mn-lt"/>
+        <a:ea typeface="+mn-ea"/>
+        <a:cs typeface="+mn-cs"/>
+      </a:defRPr>
+    </a:lvl9pPr>
+  </p:notesStyle>
+</p:notesMaster>
+</file>
+
+<file path=ppt/notesSlides/notesSlide1.xml><?xml version="1.0" encoding="utf-8"?>
+<p:notes xmlns:a="http://schemas.openxmlformats.org/drawingml/2006/main" xmlns:p="http://schemas.openxmlformats.org/presentationml/2006/main" xmlns:r="http://schemas.openxmlformats.org/officeDocument/2006/relationships">
+  <p:cSld>
+    <p:spTree>
+      <p:nvGrpSpPr>
+        <p:cNvPr id="1" name=""/>
+        <p:cNvGrpSpPr/>
+        <p:nvPr/>
+      </p:nvGrpSpPr>
+      <p:grpSpPr>
+        <a:xfrm>
+          <a:off x="0" y="0"/>
+          <a:ext cx="0" cy="0"/>
+          <a:chOff x="0" y="0"/>
+          <a:chExt cx="0" cy="0"/>
+        </a:xfrm>
+      </p:grpSpPr>
+      <p:sp>
+        <p:nvSpPr>
+          <p:cNvPr id="2" name="Slide Image Placeholder 1"/>
+          <p:cNvSpPr>
+            <a:spLocks noGrp="1"/>
+          </p:cNvSpPr>
+          <p:nvPr>
+            <p:ph type="sldImg" idx="2"/>
+          </p:nvPr>
+        </p:nvSpPr>
+        <p:spPr/>
+      </p:sp>
+      <p:sp>
+        <p:nvSpPr>
+          <p:cNvPr id="3" name="Notes Placeholder 2"/>
+          <p:cNvSpPr>
+            <a:spLocks noGrp="1"/>
+          </p:cNvSpPr>
+          <p:nvPr>
+            <p:ph type="body" idx="3" sz="quarter"/>
+          </p:nvPr>
+        </p:nvSpPr>
+        <p:spPr/>
+        <p:txBody>
+          <a:bodyPr/>
+          <a:lstStyle/>
+          <a:p>
+            <a:r>
+              <a:t>Buenas tardes. Mi trabajo se titula Deteccion automatica de eventos adversos hospitalarios en notas clinicas mediante PLN. Trabajo final del curso MIA-10 con el Dr. Wester Zela. Cuatro cifras que resumen lo que van a ver: 70,000 notas clinicas de modelado, casi 34 horas de computo medido, 7 modelos comparados, y un AUC final de 0.843 — parte de la historia es por que ese numero es MENOR que uno que obtuve antes, y por que eso es una mejora. (30 segundos, no mas.)</a:t>
+            </a:r>
+          </a:p>
+        </p:txBody>
+      </p:sp>
+      <p:sp>
+        <p:nvSpPr>
+          <p:cNvPr id="4" name="Slide Number Placeholder 3"/>
+          <p:cNvSpPr>
+            <a:spLocks noGrp="1"/>
+          </p:cNvSpPr>
+          <p:nvPr>
+            <p:ph type="sldNum" idx="5" sz="quarter"/>
+          </p:nvPr>
+        </p:nvSpPr>
+        <p:spPr/>
+      </p:sp>
+    </p:spTree>
+  </p:cSld>
+  <p:clrMapOvr>
+    <a:masterClrMapping/>
+  </p:clrMapOvr>
+</p:notes>
+</file>
+
+<file path=ppt/notesSlides/notesSlide10.xml><?xml version="1.0" encoding="utf-8"?>
+<p:notes xmlns:a="http://schemas.openxmlformats.org/drawingml/2006/main" xmlns:p="http://schemas.openxmlformats.org/presentationml/2006/main" xmlns:r="http://schemas.openxmlformats.org/officeDocument/2006/relationships">
+  <p:cSld>
+    <p:spTree>
+      <p:nvGrpSpPr>
+        <p:cNvPr id="1" name=""/>
+        <p:cNvGrpSpPr/>
+        <p:nvPr/>
+      </p:nvGrpSpPr>
+      <p:grpSpPr>
+        <a:xfrm>
+          <a:off x="0" y="0"/>
+          <a:ext cx="0" cy="0"/>
+          <a:chOff x="0" y="0"/>
+          <a:chExt cx="0" cy="0"/>
+        </a:xfrm>
+      </p:grpSpPr>
+      <p:sp>
+        <p:nvSpPr>
+          <p:cNvPr id="2" name="Slide Image Placeholder 1"/>
+          <p:cNvSpPr>
+            <a:spLocks noGrp="1"/>
+          </p:cNvSpPr>
+          <p:nvPr>
+            <p:ph type="sldImg" idx="2"/>
+          </p:nvPr>
+        </p:nvSpPr>
+        <p:spPr/>
+      </p:sp>
+      <p:sp>
+        <p:nvSpPr>
+          <p:cNvPr id="3" name="Notes Placeholder 2"/>
+          <p:cNvSpPr>
+            <a:spLocks noGrp="1"/>
+          </p:cNvSpPr>
+          <p:nvPr>
+            <p:ph type="body" idx="3" sz="quarter"/>
+          </p:nvPr>
+        </p:nvSpPr>
+        <p:spPr/>
+        <p:txBody>
+          <a:bodyPr/>
+          <a:lstStyle/>
+          <a:p>
+            <a:r>
+              <a:t>MIMIC-IV-Note: 331,793 resumenes de alta reales del Beth Israel Deaconess de Boston, 2008-2019, acceso credencializado (curso CITI + DUA). Texto clinico real con toda su suciedad. El corpus de modelado quedo en 70,000 notas: el techo lo puso la RAM al vectorizar n-gramas de caracter, y esta declarado. Numero clave de la lamina: prevalencia poblacional real 20.12% (109,775 hospitalizaciones con evento sobre 545,601). Retenerlo: decide el VPP operativo. Si preguntan por que datos americanos: no existe corpus peruano de notas con eventos etiquetados y acceso autorizado; MIMIC es el estandar mundial para desarrollar el metodo legalmente — y la validacion en espanol viene en dos laminas.</a:t>
+            </a:r>
+          </a:p>
+        </p:txBody>
+      </p:sp>
+      <p:sp>
+        <p:nvSpPr>
+          <p:cNvPr id="4" name="Slide Number Placeholder 3"/>
+          <p:cNvSpPr>
+            <a:spLocks noGrp="1"/>
+          </p:cNvSpPr>
+          <p:nvPr>
+            <p:ph type="sldNum" idx="5" sz="quarter"/>
+          </p:nvPr>
+        </p:nvSpPr>
+        <p:spPr/>
+      </p:sp>
+    </p:spTree>
+  </p:cSld>
+  <p:clrMapOvr>
+    <a:masterClrMapping/>
+  </p:clrMapOvr>
+</p:notes>
+</file>
+
+<file path=ppt/notesSlides/notesSlide11.xml><?xml version="1.0" encoding="utf-8"?>
+<p:notes xmlns:a="http://schemas.openxmlformats.org/drawingml/2006/main" xmlns:p="http://schemas.openxmlformats.org/presentationml/2006/main" xmlns:r="http://schemas.openxmlformats.org/officeDocument/2006/relationships">
+  <p:cSld>
+    <p:spTree>
+      <p:nvGrpSpPr>
+        <p:cNvPr id="1" name=""/>
+        <p:cNvGrpSpPr/>
+        <p:nvPr/>
+      </p:nvGrpSpPr>
+      <p:grpSpPr>
+        <a:xfrm>
+          <a:off x="0" y="0"/>
+          <a:ext cx="0" cy="0"/>
+          <a:chOff x="0" y="0"/>
+          <a:chExt cx="0" cy="0"/>
+        </a:xfrm>
+      </p:grpSpPr>
+      <p:sp>
+        <p:nvSpPr>
+          <p:cNvPr id="2" name="Slide Image Placeholder 1"/>
+          <p:cNvSpPr>
+            <a:spLocks noGrp="1"/>
+          </p:cNvSpPr>
+          <p:nvPr>
+            <p:ph type="sldImg" idx="2"/>
+          </p:nvPr>
+        </p:nvSpPr>
+        <p:spPr/>
+      </p:sp>
+      <p:sp>
+        <p:nvSpPr>
+          <p:cNvPr id="3" name="Notes Placeholder 2"/>
+          <p:cNvSpPr>
+            <a:spLocks noGrp="1"/>
+          </p:cNvSpPr>
+          <p:nvPr>
+            <p:ph type="body" idx="3" sz="quarter"/>
+          </p:nvPr>
+        </p:nvSpPr>
+        <p:spPr/>
+        <p:txBody>
+          <a:bodyPr/>
+          <a:lstStyle/>
+          <a:p>
+            <a:r>
+              <a:t>La otra mitad, y es peruana: 8,799 ocurrencias REALES del sistema institucional de reporte, en espanol, codificadas UNA A UNA por profesionales contra los Anexos 02 y 03. Eso es estandar de ORO (juicio humano); MIMIC es plata (codigos administrativos). Preprocesamiento: anonimizacion de identificadores en el texto libre, descarte de textos demasiado breves y 2,463 duplicados eliminados — sin deduplicar, el mismo texto caia en entrenamiento y prueba y las metricas salian infladas. Quedan 6,336 casos. Advertencia de comparabilidad (decirla ANTES de que la pregunten): el reporte describe un evento que quien escribio YA identifico; en la nota clinica hay que ENCONTRARLO. Problemas distintos; el del reporte es mas facil por construccion. No entrar en longitudes de texto.</a:t>
+            </a:r>
+          </a:p>
+        </p:txBody>
+      </p:sp>
+      <p:sp>
+        <p:nvSpPr>
+          <p:cNvPr id="4" name="Slide Number Placeholder 3"/>
+          <p:cNvSpPr>
+            <a:spLocks noGrp="1"/>
+          </p:cNvSpPr>
+          <p:nvPr>
+            <p:ph type="sldNum" idx="5" sz="quarter"/>
+          </p:nvPr>
+        </p:nvSpPr>
+        <p:spPr/>
+      </p:sp>
+    </p:spTree>
+  </p:cSld>
+  <p:clrMapOvr>
+    <a:masterClrMapping/>
+  </p:clrMapOvr>
+</p:notes>
+</file>
+
+<file path=ppt/notesSlides/notesSlide12.xml><?xml version="1.0" encoding="utf-8"?>
+<p:notes xmlns:a="http://schemas.openxmlformats.org/drawingml/2006/main" xmlns:p="http://schemas.openxmlformats.org/presentationml/2006/main" xmlns:r="http://schemas.openxmlformats.org/officeDocument/2006/relationships">
+  <p:cSld>
+    <p:spTree>
+      <p:nvGrpSpPr>
+        <p:cNvPr id="1" name=""/>
+        <p:cNvGrpSpPr/>
+        <p:nvPr/>
+      </p:nvGrpSpPr>
+      <p:grpSpPr>
+        <a:xfrm>
+          <a:off x="0" y="0"/>
+          <a:ext cx="0" cy="0"/>
+          <a:chOff x="0" y="0"/>
+          <a:chExt cx="0" cy="0"/>
+        </a:xfrm>
+      </p:grpSpPr>
+      <p:sp>
+        <p:nvSpPr>
+          <p:cNvPr id="2" name="Slide Image Placeholder 1"/>
+          <p:cNvSpPr>
+            <a:spLocks noGrp="1"/>
+          </p:cNvSpPr>
+          <p:nvPr>
+            <p:ph type="sldImg" idx="2"/>
+          </p:nvPr>
+        </p:nvSpPr>
+        <p:spPr/>
+      </p:sp>
+      <p:sp>
+        <p:nvSpPr>
+          <p:cNvPr id="3" name="Notes Placeholder 2"/>
+          <p:cNvSpPr>
+            <a:spLocks noGrp="1"/>
+          </p:cNvSpPr>
+          <p:nvPr>
+            <p:ph type="body" idx="3" sz="quarter"/>
+          </p:nvPr>
+        </p:nvSpPr>
+        <p:spPr/>
+        <p:txBody>
+          <a:bodyPr/>
+          <a:lstStyle/>
+          <a:p>
+            <a:r>
+              <a:t>Las dos correcciones con efecto medido. BUG DEL PUNTO: el mapeo guardaba A04.7 (como la norma) y MIMIC guarda A047. El cruce fallaba en silencio: 411 hospitalizaciones. Corregido y cruzando por prefijo (respeta la jerarquia CIE-10): 109,714 — factor 267x. 'El Tier A nunca fallo conceptualmente; fallo por un punto.' BUG DEL COMODIN: el patron podia atravesar la nota entera — 'hemocultivo positivo' en la pagina 1 se unia con 'cateter' en la pagina 8: dos hechos verdaderos por separado, una conclusion falsa. Acotado a 100 caracteres (mismo parrafo): cae el 63.7% de detecciones, todas espurias. Elegancia del cuadro: una correccion SUBE la cifra y la otra la BAJA — ambas hacia la verdad: el Tier A estaba ciego, el Tier B alucinaba. Verificacion del diagnostico: los patrones SIN comodin quedaron identicos (13,189 -&gt; 13,189, cero variacion); solo cayeron los que tenian .* — el defecto era el ALCANCE, no la especificidad.</a:t>
+            </a:r>
+          </a:p>
+        </p:txBody>
+      </p:sp>
+      <p:sp>
+        <p:nvSpPr>
+          <p:cNvPr id="4" name="Slide Number Placeholder 3"/>
+          <p:cNvSpPr>
+            <a:spLocks noGrp="1"/>
+          </p:cNvSpPr>
+          <p:nvPr>
+            <p:ph type="sldNum" idx="5" sz="quarter"/>
+          </p:nvPr>
+        </p:nvSpPr>
+        <p:spPr/>
+      </p:sp>
+    </p:spTree>
+  </p:cSld>
+  <p:clrMapOvr>
+    <a:masterClrMapping/>
+  </p:clrMapOvr>
+</p:notes>
+</file>
+
+<file path=ppt/notesSlides/notesSlide13.xml><?xml version="1.0" encoding="utf-8"?>
+<p:notes xmlns:a="http://schemas.openxmlformats.org/drawingml/2006/main" xmlns:p="http://schemas.openxmlformats.org/presentationml/2006/main" xmlns:r="http://schemas.openxmlformats.org/officeDocument/2006/relationships">
+  <p:cSld>
+    <p:spTree>
+      <p:nvGrpSpPr>
+        <p:cNvPr id="1" name=""/>
+        <p:cNvGrpSpPr/>
+        <p:nvPr/>
+      </p:nvGrpSpPr>
+      <p:grpSpPr>
+        <a:xfrm>
+          <a:off x="0" y="0"/>
+          <a:ext cx="0" cy="0"/>
+          <a:chOff x="0" y="0"/>
+          <a:chExt cx="0" cy="0"/>
+        </a:xfrm>
+      </p:grpSpPr>
+      <p:sp>
+        <p:nvSpPr>
+          <p:cNvPr id="2" name="Slide Image Placeholder 1"/>
+          <p:cNvSpPr>
+            <a:spLocks noGrp="1"/>
+          </p:cNvSpPr>
+          <p:nvPr>
+            <p:ph type="sldImg" idx="2"/>
+          </p:nvPr>
+        </p:nvSpPr>
+        <p:spPr/>
+      </p:sp>
+      <p:sp>
+        <p:nvSpPr>
+          <p:cNvPr id="3" name="Notes Placeholder 2"/>
+          <p:cNvSpPr>
+            <a:spLocks noGrp="1"/>
+          </p:cNvSpPr>
+          <p:nvPr>
+            <p:ph type="body" idx="3" sz="quarter"/>
+          </p:nvPr>
+        </p:nvSpPr>
+        <p:spPr/>
+        <p:txBody>
+          <a:bodyPr/>
+          <a:lstStyle/>
+          <a:p>
+            <a:r>
+              <a:t>Como se convierte el texto en numeros: TF-IDF con dos vistas. Palabra (1-2 gramas): capta conceptos como 'wound infection'. Caracter (3-5 letras): 'infec' captura infection/infected/infeccion — sobrevive a abreviaturas y errores del texto clinico. La logica TF-IDF: pesa mas lo frecuente en ESTA nota pero raro en el corpus — la intuicion del lector experto: 'reintubacion' informa, 'paciente' no. (Autores si preguntan: IDF de Karen Sparck Jones 1972; SVM de Vapnik/Cortes 1995; uso scikit-learn.) Y la decision de protocolo mas importante: PARTICION POR PACIENTE con GroupShuffleSplit y asercion de no solape — un mismo paciente aporta varias notas con vocabulario compartido; particionar por nota inflaria las metricas. El vectorizador se ajusta SOLO en entrenamiento.</a:t>
+            </a:r>
+          </a:p>
+        </p:txBody>
+      </p:sp>
+      <p:sp>
+        <p:nvSpPr>
+          <p:cNvPr id="4" name="Slide Number Placeholder 3"/>
+          <p:cNvSpPr>
+            <a:spLocks noGrp="1"/>
+          </p:cNvSpPr>
+          <p:nvPr>
+            <p:ph type="sldNum" idx="5" sz="quarter"/>
+          </p:nvPr>
+        </p:nvSpPr>
+        <p:spPr/>
+      </p:sp>
+    </p:spTree>
+  </p:cSld>
+  <p:clrMapOvr>
+    <a:masterClrMapping/>
+  </p:clrMapOvr>
+</p:notes>
+</file>
+
+<file path=ppt/notesSlides/notesSlide14.xml><?xml version="1.0" encoding="utf-8"?>
+<p:notes xmlns:a="http://schemas.openxmlformats.org/drawingml/2006/main" xmlns:p="http://schemas.openxmlformats.org/presentationml/2006/main" xmlns:r="http://schemas.openxmlformats.org/officeDocument/2006/relationships">
+  <p:cSld>
+    <p:spTree>
+      <p:nvGrpSpPr>
+        <p:cNvPr id="1" name=""/>
+        <p:cNvGrpSpPr/>
+        <p:nvPr/>
+      </p:nvGrpSpPr>
+      <p:grpSpPr>
+        <a:xfrm>
+          <a:off x="0" y="0"/>
+          <a:ext cx="0" cy="0"/>
+          <a:chOff x="0" y="0"/>
+          <a:chExt cx="0" cy="0"/>
+        </a:xfrm>
+      </p:grpSpPr>
+      <p:sp>
+        <p:nvSpPr>
+          <p:cNvPr id="2" name="Slide Image Placeholder 1"/>
+          <p:cNvSpPr>
+            <a:spLocks noGrp="1"/>
+          </p:cNvSpPr>
+          <p:nvPr>
+            <p:ph type="sldImg" idx="2"/>
+          </p:nvPr>
+        </p:nvSpPr>
+        <p:spPr/>
+      </p:sp>
+      <p:sp>
+        <p:nvSpPr>
+          <p:cNvPr id="3" name="Notes Placeholder 2"/>
+          <p:cNvSpPr>
+            <a:spLocks noGrp="1"/>
+          </p:cNvSpPr>
+          <p:nvPr>
+            <p:ph type="body" idx="3" sz="quarter"/>
+          </p:nvPr>
+        </p:nvSpPr>
+        <p:spPr/>
+        <p:txBody>
+          <a:bodyPr/>
+          <a:lstStyle/>
+          <a:p>
+            <a:r>
+              <a:t>Dos preguntas en serie. Etapa 1: hay evento adverso? — binaria, entrenada con 33,564 notas SIN evento (la clase negativa). Etapa 2: de que naturaleza? — 8 clases del Anexo 02. La clase negativa es lo que convierte un clasificador en un DETECTOR: le da el derecho a decir 'aqui no hay nada'. La consola es la prueba: seis textos triviales (un punto, 'ok', 'paciente estable'), seis abstenciones con margen negativo. Antes de esto, disparaba hasta ante un punto. Y la cascada es la honestidad: evaluar la Etapa 2 sobre positivos garantizados asume un detector perfecto; la cifra real es la de las dos etapas encadenadas — la muestro en resultados.</a:t>
+            </a:r>
+          </a:p>
+        </p:txBody>
+      </p:sp>
+      <p:sp>
+        <p:nvSpPr>
+          <p:cNvPr id="4" name="Slide Number Placeholder 3"/>
+          <p:cNvSpPr>
+            <a:spLocks noGrp="1"/>
+          </p:cNvSpPr>
+          <p:nvPr>
+            <p:ph type="sldNum" idx="5" sz="quarter"/>
+          </p:nvPr>
+        </p:nvSpPr>
+        <p:spPr/>
+      </p:sp>
+    </p:spTree>
+  </p:cSld>
+  <p:clrMapOvr>
+    <a:masterClrMapping/>
+  </p:clrMapOvr>
+</p:notes>
+</file>
+
+<file path=ppt/notesSlides/notesSlide15.xml><?xml version="1.0" encoding="utf-8"?>
+<p:notes xmlns:a="http://schemas.openxmlformats.org/drawingml/2006/main" xmlns:p="http://schemas.openxmlformats.org/presentationml/2006/main" xmlns:r="http://schemas.openxmlformats.org/officeDocument/2006/relationships">
+  <p:cSld>
+    <p:spTree>
+      <p:nvGrpSpPr>
+        <p:cNvPr id="1" name=""/>
+        <p:cNvGrpSpPr/>
+        <p:nvPr/>
+      </p:nvGrpSpPr>
+      <p:grpSpPr>
+        <a:xfrm>
+          <a:off x="0" y="0"/>
+          <a:ext cx="0" cy="0"/>
+          <a:chOff x="0" y="0"/>
+          <a:chExt cx="0" cy="0"/>
+        </a:xfrm>
+      </p:grpSpPr>
+      <p:sp>
+        <p:nvSpPr>
+          <p:cNvPr id="2" name="Slide Image Placeholder 1"/>
+          <p:cNvSpPr>
+            <a:spLocks noGrp="1"/>
+          </p:cNvSpPr>
+          <p:nvPr>
+            <p:ph type="sldImg" idx="2"/>
+          </p:nvPr>
+        </p:nvSpPr>
+        <p:spPr/>
+      </p:sp>
+      <p:sp>
+        <p:nvSpPr>
+          <p:cNvPr id="3" name="Notes Placeholder 2"/>
+          <p:cNvSpPr>
+            <a:spLocks noGrp="1"/>
+          </p:cNvSpPr>
+          <p:nvPr>
+            <p:ph type="body" idx="3" sz="quarter"/>
+          </p:nvPr>
+        </p:nvSpPr>
+        <p:spPr/>
+        <p:txBody>
+          <a:bodyPr/>
+          <a:lstStyle/>
+          <a:p>
+            <a:r>
+              <a:t>La lamina que responde lo que pidio el docente. Comandos reales: entorno virtual AISLADO (para no comprometer el interprete del sistema) con PyTorch para CUDA. Hardware: laptop HP Victus, GTX 1650 de 4 GB — hardware de estudiante, deliberado: el DUA exige procesamiento local y demuestra transferibilidad a cualquier hospital. La tabla es la factura medida de los logs: ablacion del corpus completo casi 18 horas; cada fine-tuning de transformer 3-4 horas; los cuatro TF-IDF, 1 minuto 46 segundos. Total registrado: 33 h 54 min. El contraste que importa (tarjeta granate): transformers 9 h 47 min para F1 0.354; TF-IDF 1 min 46 s para 0.459. TRESCIENTAS TREINTA Y TRES veces mas computo, para perder.</a:t>
+            </a:r>
+          </a:p>
+        </p:txBody>
+      </p:sp>
+      <p:sp>
+        <p:nvSpPr>
+          <p:cNvPr id="4" name="Slide Number Placeholder 3"/>
+          <p:cNvSpPr>
+            <a:spLocks noGrp="1"/>
+          </p:cNvSpPr>
+          <p:nvPr>
+            <p:ph type="sldNum" idx="5" sz="quarter"/>
+          </p:nvPr>
+        </p:nvSpPr>
+        <p:spPr/>
+      </p:sp>
+    </p:spTree>
+  </p:cSld>
+  <p:clrMapOvr>
+    <a:masterClrMapping/>
+  </p:clrMapOvr>
+</p:notes>
+</file>
+
+<file path=ppt/notesSlides/notesSlide16.xml><?xml version="1.0" encoding="utf-8"?>
+<p:notes xmlns:a="http://schemas.openxmlformats.org/drawingml/2006/main" xmlns:p="http://schemas.openxmlformats.org/presentationml/2006/main" xmlns:r="http://schemas.openxmlformats.org/officeDocument/2006/relationships">
+  <p:cSld>
+    <p:spTree>
+      <p:nvGrpSpPr>
+        <p:cNvPr id="1" name=""/>
+        <p:cNvGrpSpPr/>
+        <p:nvPr/>
+      </p:nvGrpSpPr>
+      <p:grpSpPr>
+        <a:xfrm>
+          <a:off x="0" y="0"/>
+          <a:ext cx="0" cy="0"/>
+          <a:chOff x="0" y="0"/>
+          <a:chExt cx="0" cy="0"/>
+        </a:xfrm>
+      </p:grpSpPr>
+      <p:sp>
+        <p:nvSpPr>
+          <p:cNvPr id="2" name="Slide Image Placeholder 1"/>
+          <p:cNvSpPr>
+            <a:spLocks noGrp="1"/>
+          </p:cNvSpPr>
+          <p:nvPr>
+            <p:ph type="sldImg" idx="2"/>
+          </p:nvPr>
+        </p:nvSpPr>
+        <p:spPr/>
+      </p:sp>
+      <p:sp>
+        <p:nvSpPr>
+          <p:cNvPr id="3" name="Notes Placeholder 2"/>
+          <p:cNvSpPr>
+            <a:spLocks noGrp="1"/>
+          </p:cNvSpPr>
+          <p:nvPr>
+            <p:ph type="body" idx="3" sz="quarter"/>
+          </p:nvPr>
+        </p:nvSpPr>
+        <p:spPr/>
+        <p:txBody>
+          <a:bodyPr/>
+          <a:lstStyle/>
+          <a:p>
+            <a:r>
+              <a:t>Salidas LITERALES de los logs, no reconstruidas. La historia: la corrida grande murio al 78.4% tras 17 horas — ahi esta el mensaje del checkpoint — y se reanudo completando el resto en 32 minutos. Ejecutar un pipeline real es disenar para el fallo. Abajo, la verificacion del comodin: CON .* caen 84%; SIN comodin, cero variacion — la prueba de que el diagnostico era correcto. Cada experimento tiene comando, log y duracion en la bitacora publica. Ofrecer aqui: 'tengo el notebook abierto, puedo ejecutarlo en vivo'.</a:t>
+            </a:r>
+          </a:p>
+        </p:txBody>
+      </p:sp>
+      <p:sp>
+        <p:nvSpPr>
+          <p:cNvPr id="4" name="Slide Number Placeholder 3"/>
+          <p:cNvSpPr>
+            <a:spLocks noGrp="1"/>
+          </p:cNvSpPr>
+          <p:nvPr>
+            <p:ph type="sldNum" idx="5" sz="quarter"/>
+          </p:nvPr>
+        </p:nvSpPr>
+        <p:spPr/>
+      </p:sp>
+    </p:spTree>
+  </p:cSld>
+  <p:clrMapOvr>
+    <a:masterClrMapping/>
+  </p:clrMapOvr>
+</p:notes>
+</file>
+
+<file path=ppt/notesSlides/notesSlide17.xml><?xml version="1.0" encoding="utf-8"?>
+<p:notes xmlns:a="http://schemas.openxmlformats.org/drawingml/2006/main" xmlns:p="http://schemas.openxmlformats.org/presentationml/2006/main" xmlns:r="http://schemas.openxmlformats.org/officeDocument/2006/relationships">
+  <p:cSld>
+    <p:spTree>
+      <p:nvGrpSpPr>
+        <p:cNvPr id="1" name=""/>
+        <p:cNvGrpSpPr/>
+        <p:nvPr/>
+      </p:nvGrpSpPr>
+      <p:grpSpPr>
+        <a:xfrm>
+          <a:off x="0" y="0"/>
+          <a:ext cx="0" cy="0"/>
+          <a:chOff x="0" y="0"/>
+          <a:chExt cx="0" cy="0"/>
+        </a:xfrm>
+      </p:grpSpPr>
+      <p:sp>
+        <p:nvSpPr>
+          <p:cNvPr id="2" name="Slide Image Placeholder 1"/>
+          <p:cNvSpPr>
+            <a:spLocks noGrp="1"/>
+          </p:cNvSpPr>
+          <p:nvPr>
+            <p:ph type="sldImg" idx="2"/>
+          </p:nvPr>
+        </p:nvSpPr>
+        <p:spPr/>
+      </p:sp>
+      <p:sp>
+        <p:nvSpPr>
+          <p:cNvPr id="3" name="Notes Placeholder 2"/>
+          <p:cNvSpPr>
+            <a:spLocks noGrp="1"/>
+          </p:cNvSpPr>
+          <p:nvPr>
+            <p:ph type="body" idx="3" sz="quarter"/>
+          </p:nvPr>
+        </p:nvSpPr>
+        <p:spPr/>
+        <p:txBody>
+          <a:bodyPr/>
+          <a:lstStyle/>
+          <a:p>
+            <a:r>
+              <a:t>El momento Zech anunciado. Version intermedia: AUC 0.973. Espectacular, publicable... y FALSO. Causa: el mapeo solo tenia CIE-10; EE.UU. adopto CIE-10 en 2015 y MIMIC va de 2008 a 2019 — toda hospitalizacion anterior quedaba negativa POR CONSTRUCCION. El modelo no aprendio eventos adversos: aprendio a distinguir la PLANTILLA documental de cada epoca. Prueba forense: su rasgo de mayor peso era 'rdwsd', un encabezado de laboratorio sin contenido clinico. Correccion: mapeo extendido a CIE-9 con equivalencias verificadas y emparejamiento por epoca A NIVEL DE NOTA — control exacto: 28.92% de era CIE-10 en positivos y en negativos, diferencia cero. Tras corregir, los rasgos importantes son clinicos: caida, revision, rechazo, reestenosis. AUC honesto: 0.843. Leccion: un AUC de 0.973 puede sostenerse entero en una senal espuria — la pregunta no es cuanto acierta el modelo, sino POR QUE acierta.</a:t>
+            </a:r>
+          </a:p>
+        </p:txBody>
+      </p:sp>
+      <p:sp>
+        <p:nvSpPr>
+          <p:cNvPr id="4" name="Slide Number Placeholder 3"/>
+          <p:cNvSpPr>
+            <a:spLocks noGrp="1"/>
+          </p:cNvSpPr>
+          <p:nvPr>
+            <p:ph type="sldNum" idx="5" sz="quarter"/>
+          </p:nvPr>
+        </p:nvSpPr>
+        <p:spPr/>
+      </p:sp>
+    </p:spTree>
+  </p:cSld>
+  <p:clrMapOvr>
+    <a:masterClrMapping/>
+  </p:clrMapOvr>
+</p:notes>
+</file>
+
+<file path=ppt/notesSlides/notesSlide18.xml><?xml version="1.0" encoding="utf-8"?>
+<p:notes xmlns:a="http://schemas.openxmlformats.org/drawingml/2006/main" xmlns:p="http://schemas.openxmlformats.org/presentationml/2006/main" xmlns:r="http://schemas.openxmlformats.org/officeDocument/2006/relationships">
+  <p:cSld>
+    <p:spTree>
+      <p:nvGrpSpPr>
+        <p:cNvPr id="1" name=""/>
+        <p:cNvGrpSpPr/>
+        <p:nvPr/>
+      </p:nvGrpSpPr>
+      <p:grpSpPr>
+        <a:xfrm>
+          <a:off x="0" y="0"/>
+          <a:ext cx="0" cy="0"/>
+          <a:chOff x="0" y="0"/>
+          <a:chExt cx="0" cy="0"/>
+        </a:xfrm>
+      </p:grpSpPr>
+      <p:sp>
+        <p:nvSpPr>
+          <p:cNvPr id="2" name="Slide Image Placeholder 1"/>
+          <p:cNvSpPr>
+            <a:spLocks noGrp="1"/>
+          </p:cNvSpPr>
+          <p:nvPr>
+            <p:ph type="sldImg" idx="2"/>
+          </p:nvPr>
+        </p:nvSpPr>
+        <p:spPr/>
+      </p:sp>
+      <p:sp>
+        <p:nvSpPr>
+          <p:cNvPr id="3" name="Notes Placeholder 2"/>
+          <p:cNvSpPr>
+            <a:spLocks noGrp="1"/>
+          </p:cNvSpPr>
+          <p:nvPr>
+            <p:ph type="body" idx="3" sz="quarter"/>
+          </p:nvPr>
+        </p:nvSpPr>
+        <p:spPr/>
+        <p:txBody>
+          <a:bodyPr/>
+          <a:lstStyle/>
+          <a:p>
+            <a:r>
+              <a:t>Detector final: sensibilidad 0.762, especificidad 0.770, AUC 0.843 — intervalos por bootstrap AGRUPADO POR PACIENTE (remuestrear notas sueltas viola la independencia y estrecha artificialmente los intervalos). El numero operativo: el VPP del test es 0.793, pero el test esta balanceado; reajustado por Bayes a la prevalencia real del 20.12%: VPP OPERATIVO 0.455. Significado: de cada 100 alertas, 45 son eventos reales — frente a 20 que encuentra la revision al azar. Multiplica por 2.26 la eficiencia del revisor capturando el 76% de los eventos. Rol declarado: FILTRO DE CRIBADO, no arbitro — no decide, prioriza. Reportar 0.455 y no 0.793 es honestidad: es la cifra con la que un servicio de calidad planifica su carga real.</a:t>
+            </a:r>
+          </a:p>
+        </p:txBody>
+      </p:sp>
+      <p:sp>
+        <p:nvSpPr>
+          <p:cNvPr id="4" name="Slide Number Placeholder 3"/>
+          <p:cNvSpPr>
+            <a:spLocks noGrp="1"/>
+          </p:cNvSpPr>
+          <p:nvPr>
+            <p:ph type="sldNum" idx="5" sz="quarter"/>
+          </p:nvPr>
+        </p:nvSpPr>
+        <p:spPr/>
+      </p:sp>
+    </p:spTree>
+  </p:cSld>
+  <p:clrMapOvr>
+    <a:masterClrMapping/>
+  </p:clrMapOvr>
+</p:notes>
+</file>
+
+<file path=ppt/notesSlides/notesSlide19.xml><?xml version="1.0" encoding="utf-8"?>
+<p:notes xmlns:a="http://schemas.openxmlformats.org/drawingml/2006/main" xmlns:p="http://schemas.openxmlformats.org/presentationml/2006/main" xmlns:r="http://schemas.openxmlformats.org/officeDocument/2006/relationships">
+  <p:cSld>
+    <p:spTree>
+      <p:nvGrpSpPr>
+        <p:cNvPr id="1" name=""/>
+        <p:cNvGrpSpPr/>
+        <p:nvPr/>
+      </p:nvGrpSpPr>
+      <p:grpSpPr>
+        <a:xfrm>
+          <a:off x="0" y="0"/>
+          <a:ext cx="0" cy="0"/>
+          <a:chOff x="0" y="0"/>
+          <a:chExt cx="0" cy="0"/>
+        </a:xfrm>
+      </p:grpSpPr>
+      <p:sp>
+        <p:nvSpPr>
+          <p:cNvPr id="2" name="Slide Image Placeholder 1"/>
+          <p:cNvSpPr>
+            <a:spLocks noGrp="1"/>
+          </p:cNvSpPr>
+          <p:nvPr>
+            <p:ph type="sldImg" idx="2"/>
+          </p:nvPr>
+        </p:nvSpPr>
+        <p:spPr/>
+      </p:sp>
+      <p:sp>
+        <p:nvSpPr>
+          <p:cNvPr id="3" name="Notes Placeholder 2"/>
+          <p:cNvSpPr>
+            <a:spLocks noGrp="1"/>
+          </p:cNvSpPr>
+          <p:nvPr>
+            <p:ph type="body" idx="3" sz="quarter"/>
+          </p:nvPr>
+        </p:nvSpPr>
+        <p:spPr/>
+        <p:txBody>
+          <a:bodyPr/>
+          <a:lstStyle/>
+          <a:p>
+            <a:r>
+              <a:t>Siete modelos, misma particion, misma semilla: comparables. Gana TF-IDF + LinearSVC con texto completo: F1-macro 0.459 en 48 segundos. El mejor transformer (ClinicalBERT ponderado): 0.354 en 4 horas de GPU. La fila MAS importante es la CUARTA: el mismo modelo campeon amputado al texto que ve BERT cae a 0.330 (-28%) con la misma arquitectura — eso AISLA la variable: el transformer no pierde por arquitectura, pierde porque su ventana de 256 tokens cubre el 9% del documento (mediana 3,148 tokens). Es pedir diagnostico a quien leyo la primera pagina de la historia. Y BioBERT (papers cientificos) queda ultimo: el lenguaje de los articulos no es el de las notas reales. Conclusion: ver todo el texto vale mas que entender mejor un fragmento; la mejora es ventana larga (Clinical-Longformer), no mas preentrenamiento.</a:t>
+            </a:r>
+          </a:p>
+        </p:txBody>
+      </p:sp>
+      <p:sp>
+        <p:nvSpPr>
+          <p:cNvPr id="4" name="Slide Number Placeholder 3"/>
+          <p:cNvSpPr>
+            <a:spLocks noGrp="1"/>
+          </p:cNvSpPr>
+          <p:nvPr>
+            <p:ph type="sldNum" idx="5" sz="quarter"/>
+          </p:nvPr>
+        </p:nvSpPr>
+        <p:spPr/>
+      </p:sp>
+    </p:spTree>
+  </p:cSld>
+  <p:clrMapOvr>
+    <a:masterClrMapping/>
+  </p:clrMapOvr>
+</p:notes>
+</file>
+
+<file path=ppt/notesSlides/notesSlide2.xml><?xml version="1.0" encoding="utf-8"?>
+<p:notes xmlns:a="http://schemas.openxmlformats.org/drawingml/2006/main" xmlns:p="http://schemas.openxmlformats.org/presentationml/2006/main" xmlns:r="http://schemas.openxmlformats.org/officeDocument/2006/relationships">
+  <p:cSld>
+    <p:spTree>
+      <p:nvGrpSpPr>
+        <p:cNvPr id="1" name=""/>
+        <p:cNvGrpSpPr/>
+        <p:nvPr/>
+      </p:nvGrpSpPr>
+      <p:grpSpPr>
+        <a:xfrm>
+          <a:off x="0" y="0"/>
+          <a:ext cx="0" cy="0"/>
+          <a:chOff x="0" y="0"/>
+          <a:chExt cx="0" cy="0"/>
+        </a:xfrm>
+      </p:grpSpPr>
+      <p:sp>
+        <p:nvSpPr>
+          <p:cNvPr id="2" name="Slide Image Placeholder 1"/>
+          <p:cNvSpPr>
+            <a:spLocks noGrp="1"/>
+          </p:cNvSpPr>
+          <p:nvPr>
+            <p:ph type="sldImg" idx="2"/>
+          </p:nvPr>
+        </p:nvSpPr>
+        <p:spPr/>
+      </p:sp>
+      <p:sp>
+        <p:nvSpPr>
+          <p:cNvPr id="3" name="Notes Placeholder 2"/>
+          <p:cNvSpPr>
+            <a:spLocks noGrp="1"/>
+          </p:cNvSpPr>
+          <p:nvPr>
+            <p:ph type="body" idx="3" sz="quarter"/>
+          </p:nvPr>
+        </p:nvSpPr>
+        <p:spPr/>
+        <p:txBody>
+          <a:bodyPr/>
+          <a:lstStyle/>
+          <a:p>
+            <a:r>
+              <a:t>Siete estaciones: contexto, planteamiento del problema, antecedentes, y la parte central — la solucion — con datos, preprocesamiento, modelamiento, COMO SE EJECUTO EL CODIGO con sus costos reales, y resultados. Cierro con conclusiones, recomendaciones y referencias. (Subrayar con la voz 'como se ejecuto el codigo': es lo que pidio el docente.)</a:t>
+            </a:r>
+          </a:p>
+        </p:txBody>
+      </p:sp>
+      <p:sp>
+        <p:nvSpPr>
+          <p:cNvPr id="4" name="Slide Number Placeholder 3"/>
+          <p:cNvSpPr>
+            <a:spLocks noGrp="1"/>
+          </p:cNvSpPr>
+          <p:nvPr>
+            <p:ph type="sldNum" idx="5" sz="quarter"/>
+          </p:nvPr>
+        </p:nvSpPr>
+        <p:spPr/>
+      </p:sp>
+    </p:spTree>
+  </p:cSld>
+  <p:clrMapOvr>
+    <a:masterClrMapping/>
+  </p:clrMapOvr>
+</p:notes>
+</file>
+
+<file path=ppt/notesSlides/notesSlide20.xml><?xml version="1.0" encoding="utf-8"?>
+<p:notes xmlns:a="http://schemas.openxmlformats.org/drawingml/2006/main" xmlns:p="http://schemas.openxmlformats.org/presentationml/2006/main" xmlns:r="http://schemas.openxmlformats.org/officeDocument/2006/relationships">
+  <p:cSld>
+    <p:spTree>
+      <p:nvGrpSpPr>
+        <p:cNvPr id="1" name=""/>
+        <p:cNvGrpSpPr/>
+        <p:nvPr/>
+      </p:nvGrpSpPr>
+      <p:grpSpPr>
+        <a:xfrm>
+          <a:off x="0" y="0"/>
+          <a:ext cx="0" cy="0"/>
+          <a:chOff x="0" y="0"/>
+          <a:chExt cx="0" cy="0"/>
+        </a:xfrm>
+      </p:grpSpPr>
+      <p:sp>
+        <p:nvSpPr>
+          <p:cNvPr id="2" name="Slide Image Placeholder 1"/>
+          <p:cNvSpPr>
+            <a:spLocks noGrp="1"/>
+          </p:cNvSpPr>
+          <p:nvPr>
+            <p:ph type="sldImg" idx="2"/>
+          </p:nvPr>
+        </p:nvSpPr>
+        <p:spPr/>
+      </p:sp>
+      <p:sp>
+        <p:nvSpPr>
+          <p:cNvPr id="3" name="Notes Placeholder 2"/>
+          <p:cNvSpPr>
+            <a:spLocks noGrp="1"/>
+          </p:cNvSpPr>
+          <p:nvPr>
+            <p:ph type="body" idx="3" sz="quarter"/>
+          </p:nvPr>
+        </p:nvSpPr>
+        <p:spPr/>
+        <p:txBody>
+          <a:bodyPr/>
+          <a:lstStyle/>
+          <a:p>
+            <a:r>
+              <a:t>Dos evaluaciones que casi nadie hace. CASCADA: Etapa 2 aislada da F1-micro 0.75; encadenada tras el detector real, 0.49 — menos 34.5%. Reportar solo la aislada sobreestimaria un tercio; reporto ambas. JUICIO EXPERTO: 163 casos anotados con protocolo ciego (interfaz oculta el veredicto del sistema, orden aleatorio, tiempo cronometrado), 78 por duplicado con un segundo evaluador independiente. Contra el consenso: sensibilidad 0.945. Analisis ampliado con todos los casos: 0.914 con intervalo a la mitad. La especificidad contra experto es 0.54, coherente con cribado. Y el dato que cierra el circulo: el 25% de los casos que la codificacion declaraba negativos son eventos REALES para el experto — el subregistro, medido con mis propios datos. Si preguntan por que la especificidad solo sobre el consenso: el piloto se muestreo por estratos definidos por la salida del sistema; leerla del total seria sesgo de verificacion.</a:t>
+            </a:r>
+          </a:p>
+        </p:txBody>
+      </p:sp>
+      <p:sp>
+        <p:nvSpPr>
+          <p:cNvPr id="4" name="Slide Number Placeholder 3"/>
+          <p:cNvSpPr>
+            <a:spLocks noGrp="1"/>
+          </p:cNvSpPr>
+          <p:nvPr>
+            <p:ph type="sldNum" idx="5" sz="quarter"/>
+          </p:nvPr>
+        </p:nvSpPr>
+        <p:spPr/>
+      </p:sp>
+    </p:spTree>
+  </p:cSld>
+  <p:clrMapOvr>
+    <a:masterClrMapping/>
+  </p:clrMapOvr>
+</p:notes>
+</file>
+
+<file path=ppt/notesSlides/notesSlide21.xml><?xml version="1.0" encoding="utf-8"?>
+<p:notes xmlns:a="http://schemas.openxmlformats.org/drawingml/2006/main" xmlns:p="http://schemas.openxmlformats.org/presentationml/2006/main" xmlns:r="http://schemas.openxmlformats.org/officeDocument/2006/relationships">
+  <p:cSld>
+    <p:spTree>
+      <p:nvGrpSpPr>
+        <p:cNvPr id="1" name=""/>
+        <p:cNvGrpSpPr/>
+        <p:nvPr/>
+      </p:nvGrpSpPr>
+      <p:grpSpPr>
+        <a:xfrm>
+          <a:off x="0" y="0"/>
+          <a:ext cx="0" cy="0"/>
+          <a:chOff x="0" y="0"/>
+          <a:chExt cx="0" cy="0"/>
+        </a:xfrm>
+      </p:grpSpPr>
+      <p:sp>
+        <p:nvSpPr>
+          <p:cNvPr id="2" name="Slide Image Placeholder 1"/>
+          <p:cNvSpPr>
+            <a:spLocks noGrp="1"/>
+          </p:cNvSpPr>
+          <p:nvPr>
+            <p:ph type="sldImg" idx="2"/>
+          </p:nvPr>
+        </p:nvSpPr>
+        <p:spPr/>
+      </p:sp>
+      <p:sp>
+        <p:nvSpPr>
+          <p:cNvPr id="3" name="Notes Placeholder 2"/>
+          <p:cNvSpPr>
+            <a:spLocks noGrp="1"/>
+          </p:cNvSpPr>
+          <p:nvPr>
+            <p:ph type="body" idx="3" sz="quarter"/>
+          </p:nvPr>
+        </p:nvSpPr>
+        <p:spPr/>
+        <p:txBody>
+          <a:bodyPr/>
+          <a:lstStyle/>
+          <a:p>
+            <a:r>
+              <a:t>Ya no es promesa: cuatro tareas medidas sobre 6,336 casos peruanos con etiqueta de oro, prediccion fuera de pliegue (cada caso predicho por un modelo que nunca lo vio). Evento adverso vs incidente — la distincion central de la norma: 86% de exactitud. Naturaleza del Anexo 02: 85%. Severidad del Anexo 03: 73%. Y por primera vez el CODIGO ESPECIFICO de evento (41 clases modelables): 76%. Ademas: los 8,799 casos estan en un Excel con codigo humano, prediccion y acierto/error marcado — revisable caso por caso. Hallazgo institucional: 'Gestion de la organizacion' era inviable en MIMIC (24 casos, F1 cero) y aqui alcanza F1 0.85 con 1,400 ejemplos — el corpus peruano rescata clases que el ingles no cubre.</a:t>
+            </a:r>
+          </a:p>
+        </p:txBody>
+      </p:sp>
+      <p:sp>
+        <p:nvSpPr>
+          <p:cNvPr id="4" name="Slide Number Placeholder 3"/>
+          <p:cNvSpPr>
+            <a:spLocks noGrp="1"/>
+          </p:cNvSpPr>
+          <p:nvPr>
+            <p:ph type="sldNum" idx="5" sz="quarter"/>
+          </p:nvPr>
+        </p:nvSpPr>
+        <p:spPr/>
+      </p:sp>
+    </p:spTree>
+  </p:cSld>
+  <p:clrMapOvr>
+    <a:masterClrMapping/>
+  </p:clrMapOvr>
+</p:notes>
+</file>
+
+<file path=ppt/notesSlides/notesSlide22.xml><?xml version="1.0" encoding="utf-8"?>
+<p:notes xmlns:a="http://schemas.openxmlformats.org/drawingml/2006/main" xmlns:p="http://schemas.openxmlformats.org/presentationml/2006/main" xmlns:r="http://schemas.openxmlformats.org/officeDocument/2006/relationships">
+  <p:cSld>
+    <p:spTree>
+      <p:nvGrpSpPr>
+        <p:cNvPr id="1" name=""/>
+        <p:cNvGrpSpPr/>
+        <p:nvPr/>
+      </p:nvGrpSpPr>
+      <p:grpSpPr>
+        <a:xfrm>
+          <a:off x="0" y="0"/>
+          <a:ext cx="0" cy="0"/>
+          <a:chOff x="0" y="0"/>
+          <a:chExt cx="0" cy="0"/>
+        </a:xfrm>
+      </p:grpSpPr>
+      <p:sp>
+        <p:nvSpPr>
+          <p:cNvPr id="2" name="Slide Image Placeholder 1"/>
+          <p:cNvSpPr>
+            <a:spLocks noGrp="1"/>
+          </p:cNvSpPr>
+          <p:nvPr>
+            <p:ph type="sldImg" idx="2"/>
+          </p:nvPr>
+        </p:nvSpPr>
+        <p:spPr/>
+      </p:sp>
+      <p:sp>
+        <p:nvSpPr>
+          <p:cNvPr id="3" name="Notes Placeholder 2"/>
+          <p:cNvSpPr>
+            <a:spLocks noGrp="1"/>
+          </p:cNvSpPr>
+          <p:nvPr>
+            <p:ph type="body" idx="3" sz="quarter"/>
+          </p:nvPr>
+        </p:nvSpPr>
+        <p:spPr/>
+        <p:txBody>
+          <a:bodyPr/>
+          <a:lstStyle/>
+          <a:p>
+            <a:r>
+              <a:t>Ultima caja del diagrama; breve porque excede el alcance de PLN del curso. Lo detectado alimenta la matriz de priorizacion institucional — la vigente en EsSalud — que combina frecuencia e impacto y asigna banda (Verde/Amarillo/Rojo) y RESPONSABLE: servicio, departamento o direccion segun la banda. Es la diferencia entre un modelo que clasifica y un sistema que gestiona. (30-40 segundos maximo.)</a:t>
+            </a:r>
+          </a:p>
+        </p:txBody>
+      </p:sp>
+      <p:sp>
+        <p:nvSpPr>
+          <p:cNvPr id="4" name="Slide Number Placeholder 3"/>
+          <p:cNvSpPr>
+            <a:spLocks noGrp="1"/>
+          </p:cNvSpPr>
+          <p:nvPr>
+            <p:ph type="sldNum" idx="5" sz="quarter"/>
+          </p:nvPr>
+        </p:nvSpPr>
+        <p:spPr/>
+      </p:sp>
+    </p:spTree>
+  </p:cSld>
+  <p:clrMapOvr>
+    <a:masterClrMapping/>
+  </p:clrMapOvr>
+</p:notes>
+</file>
+
+<file path=ppt/notesSlides/notesSlide23.xml><?xml version="1.0" encoding="utf-8"?>
+<p:notes xmlns:a="http://schemas.openxmlformats.org/drawingml/2006/main" xmlns:p="http://schemas.openxmlformats.org/presentationml/2006/main" xmlns:r="http://schemas.openxmlformats.org/officeDocument/2006/relationships">
+  <p:cSld>
+    <p:spTree>
+      <p:nvGrpSpPr>
+        <p:cNvPr id="1" name=""/>
+        <p:cNvGrpSpPr/>
+        <p:nvPr/>
+      </p:nvGrpSpPr>
+      <p:grpSpPr>
+        <a:xfrm>
+          <a:off x="0" y="0"/>
+          <a:ext cx="0" cy="0"/>
+          <a:chOff x="0" y="0"/>
+          <a:chExt cx="0" cy="0"/>
+        </a:xfrm>
+      </p:grpSpPr>
+      <p:sp>
+        <p:nvSpPr>
+          <p:cNvPr id="2" name="Slide Image Placeholder 1"/>
+          <p:cNvSpPr>
+            <a:spLocks noGrp="1"/>
+          </p:cNvSpPr>
+          <p:nvPr>
+            <p:ph type="sldImg" idx="2"/>
+          </p:nvPr>
+        </p:nvSpPr>
+        <p:spPr/>
+      </p:sp>
+      <p:sp>
+        <p:nvSpPr>
+          <p:cNvPr id="3" name="Notes Placeholder 2"/>
+          <p:cNvSpPr>
+            <a:spLocks noGrp="1"/>
+          </p:cNvSpPr>
+          <p:nvPr>
+            <p:ph type="body" idx="3" sz="quarter"/>
+          </p:nvPr>
+        </p:nvSpPr>
+        <p:spPr/>
+        <p:txBody>
+          <a:bodyPr/>
+          <a:lstStyle/>
+          <a:p>
+            <a:r>
+              <a:t>Destacar tres. UNO: el modelo lexico supero al transformer; la hipotesis se refuto y la causa quedo MEDIDA — ventana de contexto, no arquitectura; la mejora es secuencia larga. DOS (la principal): el aporte metodologico es la AUDITORIA de validez — siete modos de fallo, con el confusor de epoca como caso ejemplar de aprendizaje por atajo; sin ella, mis metricas habrian medido los defectos del corpus, no los eventos. TRES: concordancia con juicio experto en banda sustancial y 2.26x de eficiencia del revisor — utilidad operativa real como cribado. Las otras tres estan escritas: cascada, espanol, destino institucional.</a:t>
+            </a:r>
+          </a:p>
+        </p:txBody>
+      </p:sp>
+      <p:sp>
+        <p:nvSpPr>
+          <p:cNvPr id="4" name="Slide Number Placeholder 3"/>
+          <p:cNvSpPr>
+            <a:spLocks noGrp="1"/>
+          </p:cNvSpPr>
+          <p:nvPr>
+            <p:ph type="sldNum" idx="5" sz="quarter"/>
+          </p:nvPr>
+        </p:nvSpPr>
+        <p:spPr/>
+      </p:sp>
+    </p:spTree>
+  </p:cSld>
+  <p:clrMapOvr>
+    <a:masterClrMapping/>
+  </p:clrMapOvr>
+</p:notes>
+</file>
+
+<file path=ppt/notesSlides/notesSlide24.xml><?xml version="1.0" encoding="utf-8"?>
+<p:notes xmlns:a="http://schemas.openxmlformats.org/drawingml/2006/main" xmlns:p="http://schemas.openxmlformats.org/presentationml/2006/main" xmlns:r="http://schemas.openxmlformats.org/officeDocument/2006/relationships">
+  <p:cSld>
+    <p:spTree>
+      <p:nvGrpSpPr>
+        <p:cNvPr id="1" name=""/>
+        <p:cNvGrpSpPr/>
+        <p:nvPr/>
+      </p:nvGrpSpPr>
+      <p:grpSpPr>
+        <a:xfrm>
+          <a:off x="0" y="0"/>
+          <a:ext cx="0" cy="0"/>
+          <a:chOff x="0" y="0"/>
+          <a:chExt cx="0" cy="0"/>
+        </a:xfrm>
+      </p:grpSpPr>
+      <p:sp>
+        <p:nvSpPr>
+          <p:cNvPr id="2" name="Slide Image Placeholder 1"/>
+          <p:cNvSpPr>
+            <a:spLocks noGrp="1"/>
+          </p:cNvSpPr>
+          <p:nvPr>
+            <p:ph type="sldImg" idx="2"/>
+          </p:nvPr>
+        </p:nvSpPr>
+        <p:spPr/>
+      </p:sp>
+      <p:sp>
+        <p:nvSpPr>
+          <p:cNvPr id="3" name="Notes Placeholder 2"/>
+          <p:cNvSpPr>
+            <a:spLocks noGrp="1"/>
+          </p:cNvSpPr>
+          <p:nvPr>
+            <p:ph type="body" idx="3" sz="quarter"/>
+          </p:nvPr>
+        </p:nvSpPr>
+        <p:spPr/>
+        <p:txBody>
+          <a:bodyPr/>
+          <a:lstStyle/>
+          <a:p>
+            <a:r>
+              <a:t>Decirlas con calma: SUMAN credibilidad. Las metricas sobre MIMIC miden acuerdo con codigos (estandar de plata), no verdad clinica — por eso existe la validacion experta. Esa validacion esta restringida a eventos de infeccion. El conjunto de prueba se reutilizo entre iteraciones — sesgo optimista no cuantificado, declarado; el umbral no se ajusto como mitigacion. Y el autor participo como anotador — mitigado con interfaz ciega, orden aleatorio, cronometraje y segundo evaluador independiente. Ninguna limitacion es oculta; todas tienen mitigacion documentada.</a:t>
+            </a:r>
+          </a:p>
+        </p:txBody>
+      </p:sp>
+      <p:sp>
+        <p:nvSpPr>
+          <p:cNvPr id="4" name="Slide Number Placeholder 3"/>
+          <p:cNvSpPr>
+            <a:spLocks noGrp="1"/>
+          </p:cNvSpPr>
+          <p:nvPr>
+            <p:ph type="sldNum" idx="5" sz="quarter"/>
+          </p:nvPr>
+        </p:nvSpPr>
+        <p:spPr/>
+      </p:sp>
+    </p:spTree>
+  </p:cSld>
+  <p:clrMapOvr>
+    <a:masterClrMapping/>
+  </p:clrMapOvr>
+</p:notes>
+</file>
+
+<file path=ppt/notesSlides/notesSlide25.xml><?xml version="1.0" encoding="utf-8"?>
+<p:notes xmlns:a="http://schemas.openxmlformats.org/drawingml/2006/main" xmlns:p="http://schemas.openxmlformats.org/presentationml/2006/main" xmlns:r="http://schemas.openxmlformats.org/officeDocument/2006/relationships">
+  <p:cSld>
+    <p:spTree>
+      <p:nvGrpSpPr>
+        <p:cNvPr id="1" name=""/>
+        <p:cNvGrpSpPr/>
+        <p:nvPr/>
+      </p:nvGrpSpPr>
+      <p:grpSpPr>
+        <a:xfrm>
+          <a:off x="0" y="0"/>
+          <a:ext cx="0" cy="0"/>
+          <a:chOff x="0" y="0"/>
+          <a:chExt cx="0" cy="0"/>
+        </a:xfrm>
+      </p:grpSpPr>
+      <p:sp>
+        <p:nvSpPr>
+          <p:cNvPr id="2" name="Slide Image Placeholder 1"/>
+          <p:cNvSpPr>
+            <a:spLocks noGrp="1"/>
+          </p:cNvSpPr>
+          <p:nvPr>
+            <p:ph type="sldImg" idx="2"/>
+          </p:nvPr>
+        </p:nvSpPr>
+        <p:spPr/>
+      </p:sp>
+      <p:sp>
+        <p:nvSpPr>
+          <p:cNvPr id="3" name="Notes Placeholder 2"/>
+          <p:cNvSpPr>
+            <a:spLocks noGrp="1"/>
+          </p:cNvSpPr>
+          <p:nvPr>
+            <p:ph type="body" idx="3" sz="quarter"/>
+          </p:nvPr>
+        </p:nvSpPr>
+        <p:spPr/>
+        <p:txBody>
+          <a:bodyPr/>
+          <a:lstStyle/>
+          <a:p>
+            <a:r>
+              <a:t>Tres lineas, cada una anclada en un hallazgo. (1) Clinical-Longformer — ventana de 4,096 tokens: mi experimento demostro que el cuello de botella es el contexto; es una prediccion verificable. (2) Cuando exista acceso institucional: entrenar sobre notas clinicas peruanas con un encoder en espanol — el ERSP ya demostro que la taxonomia es aprendible en nuestro idioma. (3) Piloto institucional del cribado, con el VPP 0.455 como parametro de planificacion de carga.</a:t>
+            </a:r>
+          </a:p>
+        </p:txBody>
+      </p:sp>
+      <p:sp>
+        <p:nvSpPr>
+          <p:cNvPr id="4" name="Slide Number Placeholder 3"/>
+          <p:cNvSpPr>
+            <a:spLocks noGrp="1"/>
+          </p:cNvSpPr>
+          <p:nvPr>
+            <p:ph type="sldNum" idx="5" sz="quarter"/>
+          </p:nvPr>
+        </p:nvSpPr>
+        <p:spPr/>
+      </p:sp>
+    </p:spTree>
+  </p:cSld>
+  <p:clrMapOvr>
+    <a:masterClrMapping/>
+  </p:clrMapOvr>
+</p:notes>
+</file>
+
+<file path=ppt/notesSlides/notesSlide26.xml><?xml version="1.0" encoding="utf-8"?>
+<p:notes xmlns:a="http://schemas.openxmlformats.org/drawingml/2006/main" xmlns:p="http://schemas.openxmlformats.org/presentationml/2006/main" xmlns:r="http://schemas.openxmlformats.org/officeDocument/2006/relationships">
+  <p:cSld>
+    <p:spTree>
+      <p:nvGrpSpPr>
+        <p:cNvPr id="1" name=""/>
+        <p:cNvGrpSpPr/>
+        <p:nvPr/>
+      </p:nvGrpSpPr>
+      <p:grpSpPr>
+        <a:xfrm>
+          <a:off x="0" y="0"/>
+          <a:ext cx="0" cy="0"/>
+          <a:chOff x="0" y="0"/>
+          <a:chExt cx="0" cy="0"/>
+        </a:xfrm>
+      </p:grpSpPr>
+      <p:sp>
+        <p:nvSpPr>
+          <p:cNvPr id="2" name="Slide Image Placeholder 1"/>
+          <p:cNvSpPr>
+            <a:spLocks noGrp="1"/>
+          </p:cNvSpPr>
+          <p:nvPr>
+            <p:ph type="sldImg" idx="2"/>
+          </p:nvPr>
+        </p:nvSpPr>
+        <p:spPr/>
+      </p:sp>
+      <p:sp>
+        <p:nvSpPr>
+          <p:cNvPr id="3" name="Notes Placeholder 2"/>
+          <p:cNvSpPr>
+            <a:spLocks noGrp="1"/>
+          </p:cNvSpPr>
+          <p:nvPr>
+            <p:ph type="body" idx="3" sz="quarter"/>
+          </p:nvPr>
+        </p:nvSpPr>
+        <p:spPr/>
+        <p:txBody>
+          <a:bodyPr/>
+          <a:lstStyle/>
+          <a:p>
+            <a:r>
+              <a:t>34 fuentes en el articulo. Destacar solo: MIMIC-IV/PhysioNet, Ratner (Snorkel), Geirhos (shortcut learning), Zech (el caso clinico), Li 2022 (Clinical-Longformer) y la Directiva de EsSalud con los Anexos 02 y 03. JAMAS leerlas. (10 segundos.)</a:t>
+            </a:r>
+          </a:p>
+        </p:txBody>
+      </p:sp>
+      <p:sp>
+        <p:nvSpPr>
+          <p:cNvPr id="4" name="Slide Number Placeholder 3"/>
+          <p:cNvSpPr>
+            <a:spLocks noGrp="1"/>
+          </p:cNvSpPr>
+          <p:nvPr>
+            <p:ph type="sldNum" idx="5" sz="quarter"/>
+          </p:nvPr>
+        </p:nvSpPr>
+        <p:spPr/>
+      </p:sp>
+    </p:spTree>
+  </p:cSld>
+  <p:clrMapOvr>
+    <a:masterClrMapping/>
+  </p:clrMapOvr>
+</p:notes>
+</file>
+
+<file path=ppt/notesSlides/notesSlide27.xml><?xml version="1.0" encoding="utf-8"?>
+<p:notes xmlns:a="http://schemas.openxmlformats.org/drawingml/2006/main" xmlns:p="http://schemas.openxmlformats.org/presentationml/2006/main" xmlns:r="http://schemas.openxmlformats.org/officeDocument/2006/relationships">
+  <p:cSld>
+    <p:spTree>
+      <p:nvGrpSpPr>
+        <p:cNvPr id="1" name=""/>
+        <p:cNvGrpSpPr/>
+        <p:nvPr/>
+      </p:nvGrpSpPr>
+      <p:grpSpPr>
+        <a:xfrm>
+          <a:off x="0" y="0"/>
+          <a:ext cx="0" cy="0"/>
+          <a:chOff x="0" y="0"/>
+          <a:chExt cx="0" cy="0"/>
+        </a:xfrm>
+      </p:grpSpPr>
+      <p:sp>
+        <p:nvSpPr>
+          <p:cNvPr id="2" name="Slide Image Placeholder 1"/>
+          <p:cNvSpPr>
+            <a:spLocks noGrp="1"/>
+          </p:cNvSpPr>
+          <p:nvPr>
+            <p:ph type="sldImg" idx="2"/>
+          </p:nvPr>
+        </p:nvSpPr>
+        <p:spPr/>
+      </p:sp>
+      <p:sp>
+        <p:nvSpPr>
+          <p:cNvPr id="3" name="Notes Placeholder 2"/>
+          <p:cNvSpPr>
+            <a:spLocks noGrp="1"/>
+          </p:cNvSpPr>
+          <p:nvPr>
+            <p:ph type="body" idx="3" sz="quarter"/>
+          </p:nvPr>
+        </p:nvSpPr>
+        <p:spPr/>
+        <p:txBody>
+          <a:bodyPr/>
+          <a:lstStyle/>
+          <a:p>
+            <a:r>
+              <a:t>La idea que resume el trabajo: empece con un AUC de 0.973 y termine con 0.843 — y ese descenso es la mayor contribucion, porque el primero media un atajo y el segundo mide el fenomeno. En deteccion de eventos adversos, donde cada falso negativo es un dano invisible para la gestion, el aporte no es una metrica alta: es una metrica en la que se puede CONFIAR. El codigo es publico, la bitacora es auditable y el sistema ya habla espanol. Muchas gracias.</a:t>
+            </a:r>
+          </a:p>
+        </p:txBody>
+      </p:sp>
+      <p:sp>
+        <p:nvSpPr>
+          <p:cNvPr id="4" name="Slide Number Placeholder 3"/>
+          <p:cNvSpPr>
+            <a:spLocks noGrp="1"/>
+          </p:cNvSpPr>
+          <p:nvPr>
+            <p:ph type="sldNum" idx="5" sz="quarter"/>
+          </p:nvPr>
+        </p:nvSpPr>
+        <p:spPr/>
+      </p:sp>
+    </p:spTree>
+  </p:cSld>
+  <p:clrMapOvr>
+    <a:masterClrMapping/>
+  </p:clrMapOvr>
+</p:notes>
+</file>
+
+<file path=ppt/notesSlides/notesSlide3.xml><?xml version="1.0" encoding="utf-8"?>
+<p:notes xmlns:a="http://schemas.openxmlformats.org/drawingml/2006/main" xmlns:p="http://schemas.openxmlformats.org/presentationml/2006/main" xmlns:r="http://schemas.openxmlformats.org/officeDocument/2006/relationships">
+  <p:cSld>
+    <p:spTree>
+      <p:nvGrpSpPr>
+        <p:cNvPr id="1" name=""/>
+        <p:cNvGrpSpPr/>
+        <p:nvPr/>
+      </p:nvGrpSpPr>
+      <p:grpSpPr>
+        <a:xfrm>
+          <a:off x="0" y="0"/>
+          <a:ext cx="0" cy="0"/>
+          <a:chOff x="0" y="0"/>
+          <a:chExt cx="0" cy="0"/>
+        </a:xfrm>
+      </p:grpSpPr>
+      <p:sp>
+        <p:nvSpPr>
+          <p:cNvPr id="2" name="Slide Image Placeholder 1"/>
+          <p:cNvSpPr>
+            <a:spLocks noGrp="1"/>
+          </p:cNvSpPr>
+          <p:nvPr>
+            <p:ph type="sldImg" idx="2"/>
+          </p:nvPr>
+        </p:nvSpPr>
+        <p:spPr/>
+      </p:sp>
+      <p:sp>
+        <p:nvSpPr>
+          <p:cNvPr id="3" name="Notes Placeholder 2"/>
+          <p:cNvSpPr>
+            <a:spLocks noGrp="1"/>
+          </p:cNvSpPr>
+          <p:nvPr>
+            <p:ph type="body" idx="3" sz="quarter"/>
+          </p:nvPr>
+        </p:nvSpPr>
+        <p:spPr/>
+        <p:txBody>
+          <a:bodyPr/>
+          <a:lstStyle/>
+          <a:p>
+            <a:r>
+              <a:t>El concepto primero: un evento adverso es un dano NO intencional causado por la atencion de salud, no por la enfermedad. Ejemplo: una neumonia puede ser el motivo de ingreso (no es evento) o adquirida por el ventilador durante la estancia (si lo es). Esa distincion es dificil hasta para un humano y persigue todo el trabajo. La vara de medir es normativa: el Anexo 02 de la Directiva GG-ESSALUD-2021, con 231 eventos en 12 naturalezas. No invente categorias: uso las oficiales.</a:t>
+            </a:r>
+          </a:p>
+        </p:txBody>
+      </p:sp>
+      <p:sp>
+        <p:nvSpPr>
+          <p:cNvPr id="4" name="Slide Number Placeholder 3"/>
+          <p:cNvSpPr>
+            <a:spLocks noGrp="1"/>
+          </p:cNvSpPr>
+          <p:nvPr>
+            <p:ph type="sldNum" idx="5" sz="quarter"/>
+          </p:nvPr>
+        </p:nvSpPr>
+        <p:spPr/>
+      </p:sp>
+    </p:spTree>
+  </p:cSld>
+  <p:clrMapOvr>
+    <a:masterClrMapping/>
+  </p:clrMapOvr>
+</p:notes>
+</file>
+
+<file path=ppt/notesSlides/notesSlide4.xml><?xml version="1.0" encoding="utf-8"?>
+<p:notes xmlns:a="http://schemas.openxmlformats.org/drawingml/2006/main" xmlns:p="http://schemas.openxmlformats.org/presentationml/2006/main" xmlns:r="http://schemas.openxmlformats.org/officeDocument/2006/relationships">
+  <p:cSld>
+    <p:spTree>
+      <p:nvGrpSpPr>
+        <p:cNvPr id="1" name=""/>
+        <p:cNvGrpSpPr/>
+        <p:nvPr/>
+      </p:nvGrpSpPr>
+      <p:grpSpPr>
+        <a:xfrm>
+          <a:off x="0" y="0"/>
+          <a:ext cx="0" cy="0"/>
+          <a:chOff x="0" y="0"/>
+          <a:chExt cx="0" cy="0"/>
+        </a:xfrm>
+      </p:grpSpPr>
+      <p:sp>
+        <p:nvSpPr>
+          <p:cNvPr id="2" name="Slide Image Placeholder 1"/>
+          <p:cNvSpPr>
+            <a:spLocks noGrp="1"/>
+          </p:cNvSpPr>
+          <p:nvPr>
+            <p:ph type="sldImg" idx="2"/>
+          </p:nvPr>
+        </p:nvSpPr>
+        <p:spPr/>
+      </p:sp>
+      <p:sp>
+        <p:nvSpPr>
+          <p:cNvPr id="3" name="Notes Placeholder 2"/>
+          <p:cNvSpPr>
+            <a:spLocks noGrp="1"/>
+          </p:cNvSpPr>
+          <p:nvPr>
+            <p:ph type="body" idx="3" sz="quarter"/>
+          </p:nvPr>
+        </p:nvSpPr>
+        <p:spPr/>
+        <p:txBody>
+          <a:bodyPr/>
+          <a:lstStyle/>
+          <a:p>
+            <a:r>
+              <a:t>La notificacion es manual y voluntaria; el subregistro estimado es cercano al 72%: de cada 10 eventos, 7 nunca llegan a calidad. La paradoja que motiva el trabajo: la informacion SI existe — el medico que atendio la complicacion la escribio en la nota clinica. Lo que no existe es la capacidad humana de leer el 100% de las notas. Pregunta de investigacion: puede un sistema de PLN leerlas y detectar los eventos con fiabilidad comparable al juicio experto? (Hablar desde la experiencia de gestion: es mi terreno.)</a:t>
+            </a:r>
+          </a:p>
+        </p:txBody>
+      </p:sp>
+      <p:sp>
+        <p:nvSpPr>
+          <p:cNvPr id="4" name="Slide Number Placeholder 3"/>
+          <p:cNvSpPr>
+            <a:spLocks noGrp="1"/>
+          </p:cNvSpPr>
+          <p:nvPr>
+            <p:ph type="sldNum" idx="5" sz="quarter"/>
+          </p:nvPr>
+        </p:nvSpPr>
+        <p:spPr/>
+      </p:sp>
+    </p:spTree>
+  </p:cSld>
+  <p:clrMapOvr>
+    <a:masterClrMapping/>
+  </p:clrMapOvr>
+</p:notes>
+</file>
+
+<file path=ppt/notesSlides/notesSlide5.xml><?xml version="1.0" encoding="utf-8"?>
+<p:notes xmlns:a="http://schemas.openxmlformats.org/drawingml/2006/main" xmlns:p="http://schemas.openxmlformats.org/presentationml/2006/main" xmlns:r="http://schemas.openxmlformats.org/officeDocument/2006/relationships">
+  <p:cSld>
+    <p:spTree>
+      <p:nvGrpSpPr>
+        <p:cNvPr id="1" name=""/>
+        <p:cNvGrpSpPr/>
+        <p:nvPr/>
+      </p:nvGrpSpPr>
+      <p:grpSpPr>
+        <a:xfrm>
+          <a:off x="0" y="0"/>
+          <a:ext cx="0" cy="0"/>
+          <a:chOff x="0" y="0"/>
+          <a:chExt cx="0" cy="0"/>
+        </a:xfrm>
+      </p:grpSpPr>
+      <p:sp>
+        <p:nvSpPr>
+          <p:cNvPr id="2" name="Slide Image Placeholder 1"/>
+          <p:cNvSpPr>
+            <a:spLocks noGrp="1"/>
+          </p:cNvSpPr>
+          <p:nvPr>
+            <p:ph type="sldImg" idx="2"/>
+          </p:nvPr>
+        </p:nvSpPr>
+        <p:spPr/>
+      </p:sp>
+      <p:sp>
+        <p:nvSpPr>
+          <p:cNvPr id="3" name="Notes Placeholder 2"/>
+          <p:cNvSpPr>
+            <a:spLocks noGrp="1"/>
+          </p:cNvSpPr>
+          <p:nvPr>
+            <p:ph type="body" idx="3" sz="quarter"/>
+          </p:nvPr>
+        </p:nvSpPr>
+        <p:spPr/>
+        <p:txBody>
+          <a:bodyPr/>
+          <a:lstStyle/>
+          <a:p>
+            <a:r>
+              <a:t>Cinco objetivos especificos, todos cumplidos: corpus por supervision debil (70,000 notas); comparacion clasico vs transformers (7 modelos); priorizacion institucional; validacion experta (163 casos con juicio experto); y transferencia al espanol (hecha, con datos peruanos reales). Transparencia: la hipotesis central — que el transformer superaria al modelo lexico — SE REFUTO. Un resultado negativo bien medido es un resultado: mas adelante muestro por que perdio y cuanto costo comprobarlo. Si preguntan si es un fracaso: lo seria no poder explicar por que fallo; medi la causa (la ventana de contexto) y eso define la linea de mejora.</a:t>
+            </a:r>
+          </a:p>
+        </p:txBody>
+      </p:sp>
+      <p:sp>
+        <p:nvSpPr>
+          <p:cNvPr id="4" name="Slide Number Placeholder 3"/>
+          <p:cNvSpPr>
+            <a:spLocks noGrp="1"/>
+          </p:cNvSpPr>
+          <p:nvPr>
+            <p:ph type="sldNum" idx="5" sz="quarter"/>
+          </p:nvPr>
+        </p:nvSpPr>
+        <p:spPr/>
+      </p:sp>
+    </p:spTree>
+  </p:cSld>
+  <p:clrMapOvr>
+    <a:masterClrMapping/>
+  </p:clrMapOvr>
+</p:notes>
+</file>
+
+<file path=ppt/notesSlides/notesSlide6.xml><?xml version="1.0" encoding="utf-8"?>
+<p:notes xmlns:a="http://schemas.openxmlformats.org/drawingml/2006/main" xmlns:p="http://schemas.openxmlformats.org/presentationml/2006/main" xmlns:r="http://schemas.openxmlformats.org/officeDocument/2006/relationships">
+  <p:cSld>
+    <p:spTree>
+      <p:nvGrpSpPr>
+        <p:cNvPr id="1" name=""/>
+        <p:cNvGrpSpPr/>
+        <p:nvPr/>
+      </p:nvGrpSpPr>
+      <p:grpSpPr>
+        <a:xfrm>
+          <a:off x="0" y="0"/>
+          <a:ext cx="0" cy="0"/>
+          <a:chOff x="0" y="0"/>
+          <a:chExt cx="0" cy="0"/>
+        </a:xfrm>
+      </p:grpSpPr>
+      <p:sp>
+        <p:nvSpPr>
+          <p:cNvPr id="2" name="Slide Image Placeholder 1"/>
+          <p:cNvSpPr>
+            <a:spLocks noGrp="1"/>
+          </p:cNvSpPr>
+          <p:nvPr>
+            <p:ph type="sldImg" idx="2"/>
+          </p:nvPr>
+        </p:nvSpPr>
+        <p:spPr/>
+      </p:sp>
+      <p:sp>
+        <p:nvSpPr>
+          <p:cNvPr id="3" name="Notes Placeholder 2"/>
+          <p:cNvSpPr>
+            <a:spLocks noGrp="1"/>
+          </p:cNvSpPr>
+          <p:nvPr>
+            <p:ph type="body" idx="3" sz="quarter"/>
+          </p:nvPr>
+        </p:nvSpPr>
+        <p:spPr/>
+        <p:txBody>
+          <a:bodyPr/>
+          <a:lstStyle/>
+          <a:p>
+            <a:r>
+              <a:t>Tres cuerpos de literatura: (1) Supervision debil — paradigma Snorkel de Stanford: etiquetar con reglas programaticas acepta ruido a cambio de escala; la validez de las reglas HAY que auditarla — corazon de mi trabajo. (2) Aprendizaje por atajo — Geirhos 2020: el modelo resuelve por la via estadisticamente barata, no la correcta. Caso Zech 2018: detector de neumonia con AUC altisimo que reconocia DE QUE HOSPITAL venia la radiografia. Retengan ese caso: me paso lo mismo y lo voy a mostrar. (3) Ventana de contexto: Clinical-Longformer supera a ClinicalBERT al ampliar la ventana — justo lo que mis datos confirman por otra via.</a:t>
+            </a:r>
+          </a:p>
+        </p:txBody>
+      </p:sp>
+      <p:sp>
+        <p:nvSpPr>
+          <p:cNvPr id="4" name="Slide Number Placeholder 3"/>
+          <p:cNvSpPr>
+            <a:spLocks noGrp="1"/>
+          </p:cNvSpPr>
+          <p:nvPr>
+            <p:ph type="sldNum" idx="5" sz="quarter"/>
+          </p:nvPr>
+        </p:nvSpPr>
+        <p:spPr/>
+      </p:sp>
+    </p:spTree>
+  </p:cSld>
+  <p:clrMapOvr>
+    <a:masterClrMapping/>
+  </p:clrMapOvr>
+</p:notes>
+</file>
+
+<file path=ppt/notesSlides/notesSlide7.xml><?xml version="1.0" encoding="utf-8"?>
+<p:notes xmlns:a="http://schemas.openxmlformats.org/drawingml/2006/main" xmlns:p="http://schemas.openxmlformats.org/presentationml/2006/main" xmlns:r="http://schemas.openxmlformats.org/officeDocument/2006/relationships">
+  <p:cSld>
+    <p:spTree>
+      <p:nvGrpSpPr>
+        <p:cNvPr id="1" name=""/>
+        <p:cNvGrpSpPr/>
+        <p:nvPr/>
+      </p:nvGrpSpPr>
+      <p:grpSpPr>
+        <a:xfrm>
+          <a:off x="0" y="0"/>
+          <a:ext cx="0" cy="0"/>
+          <a:chOff x="0" y="0"/>
+          <a:chExt cx="0" cy="0"/>
+        </a:xfrm>
+      </p:grpSpPr>
+      <p:sp>
+        <p:nvSpPr>
+          <p:cNvPr id="2" name="Slide Image Placeholder 1"/>
+          <p:cNvSpPr>
+            <a:spLocks noGrp="1"/>
+          </p:cNvSpPr>
+          <p:nvPr>
+            <p:ph type="sldImg" idx="2"/>
+          </p:nvPr>
+        </p:nvSpPr>
+        <p:spPr/>
+      </p:sp>
+      <p:sp>
+        <p:nvSpPr>
+          <p:cNvPr id="3" name="Notes Placeholder 2"/>
+          <p:cNvSpPr>
+            <a:spLocks noGrp="1"/>
+          </p:cNvSpPr>
+          <p:nvPr>
+            <p:ph type="body" idx="3" sz="quarter"/>
+          </p:nvPr>
+        </p:nvSpPr>
+        <p:spPr/>
+        <p:txBody>
+          <a:bodyPr/>
+          <a:lstStyle/>
+          <a:p>
+            <a:r>
+              <a:t>Antes de comparar hay que decidir que modelos son ADMISIBLES: filtros duros documentados. El F4 es el que casi nadie aplica: PhysioNet prohibe expresamente enviar texto de MIMIC a APIs de terceros (ChatGPT incluido) — condicion legal firmada, no preferencia. Eso descarta los LLM comerciales de entrada. F3: un LLM local de 7B no cabe en el hardware de despliegue. Dato verificable: el Open LLM Leaderboard esta ARCHIVADO por sus propios autores; citarlo hoy seria un error comprobable. Use el ranking pertinente: clasificacion, no generacion. La tarea determina la metrica y la metrica el ranking — no al reves.</a:t>
+            </a:r>
+          </a:p>
+        </p:txBody>
+      </p:sp>
+      <p:sp>
+        <p:nvSpPr>
+          <p:cNvPr id="4" name="Slide Number Placeholder 3"/>
+          <p:cNvSpPr>
+            <a:spLocks noGrp="1"/>
+          </p:cNvSpPr>
+          <p:nvPr>
+            <p:ph type="sldNum" idx="5" sz="quarter"/>
+          </p:nvPr>
+        </p:nvSpPr>
+        <p:spPr/>
+      </p:sp>
+    </p:spTree>
+  </p:cSld>
+  <p:clrMapOvr>
+    <a:masterClrMapping/>
+  </p:clrMapOvr>
+</p:notes>
+</file>
+
+<file path=ppt/notesSlides/notesSlide8.xml><?xml version="1.0" encoding="utf-8"?>
+<p:notes xmlns:a="http://schemas.openxmlformats.org/drawingml/2006/main" xmlns:p="http://schemas.openxmlformats.org/presentationml/2006/main" xmlns:r="http://schemas.openxmlformats.org/officeDocument/2006/relationships">
+  <p:cSld>
+    <p:spTree>
+      <p:nvGrpSpPr>
+        <p:cNvPr id="1" name=""/>
+        <p:cNvGrpSpPr/>
+        <p:nvPr/>
+      </p:nvGrpSpPr>
+      <p:grpSpPr>
+        <a:xfrm>
+          <a:off x="0" y="0"/>
+          <a:ext cx="0" cy="0"/>
+          <a:chOff x="0" y="0"/>
+          <a:chExt cx="0" cy="0"/>
+        </a:xfrm>
+      </p:grpSpPr>
+      <p:sp>
+        <p:nvSpPr>
+          <p:cNvPr id="2" name="Slide Image Placeholder 1"/>
+          <p:cNvSpPr>
+            <a:spLocks noGrp="1"/>
+          </p:cNvSpPr>
+          <p:nvPr>
+            <p:ph type="sldImg" idx="2"/>
+          </p:nvPr>
+        </p:nvSpPr>
+        <p:spPr/>
+      </p:sp>
+      <p:sp>
+        <p:nvSpPr>
+          <p:cNvPr id="3" name="Notes Placeholder 2"/>
+          <p:cNvSpPr>
+            <a:spLocks noGrp="1"/>
+          </p:cNvSpPr>
+          <p:nvPr>
+            <p:ph type="body" idx="3" sz="quarter"/>
+          </p:nvPr>
+        </p:nvSpPr>
+        <p:spPr/>
+        <p:txBody>
+          <a:bodyPr/>
+          <a:lstStyle/>
+          <a:p>
+            <a:r>
+              <a:t>Este diagrama es el mapa de todo; recorrerlo banda por banda con el puntero (90 seg). BANDA 1 — corpus: 331,793 notas de MIMIC-IV mas sus codigos; supervision debil con dos vias: Tier A cruza codigos CIE contra el Anexo 02, Tier B busca 35 patrones de texto con filtro de negacion NegEx. La caja amarilla: la auditoria que corrigio 7 modos de fallo. Sale el corpus de 70,000 notas, prevalencia real 20.12%. BANDA 2 — modelado: TF-IDF palabra+caracter, particion POR PACIENTE; dos etapas (detectar con abstencion, clasificar naturaleza); evaluacion honesta: cascada extremo a extremo y juicio experto en 163 casos. BANDA 3 — transferencia: 8,799 reportes peruanos reales con etiqueta de oro; destino: matriz de priorizacion institucional. Cerrar: 'todo lo que sigue es entrar a cada caja de este mapa'.</a:t>
+            </a:r>
+          </a:p>
+        </p:txBody>
+      </p:sp>
+      <p:sp>
+        <p:nvSpPr>
+          <p:cNvPr id="4" name="Slide Number Placeholder 3"/>
+          <p:cNvSpPr>
+            <a:spLocks noGrp="1"/>
+          </p:cNvSpPr>
+          <p:nvPr>
+            <p:ph type="sldNum" idx="5" sz="quarter"/>
+          </p:nvPr>
+        </p:nvSpPr>
+        <p:spPr/>
+      </p:sp>
+    </p:spTree>
+  </p:cSld>
+  <p:clrMapOvr>
+    <a:masterClrMapping/>
+  </p:clrMapOvr>
+</p:notes>
+</file>
+
+<file path=ppt/notesSlides/notesSlide9.xml><?xml version="1.0" encoding="utf-8"?>
+<p:notes xmlns:a="http://schemas.openxmlformats.org/drawingml/2006/main" xmlns:p="http://schemas.openxmlformats.org/presentationml/2006/main" xmlns:r="http://schemas.openxmlformats.org/officeDocument/2006/relationships">
+  <p:cSld>
+    <p:spTree>
+      <p:nvGrpSpPr>
+        <p:cNvPr id="1" name=""/>
+        <p:cNvGrpSpPr/>
+        <p:nvPr/>
+      </p:nvGrpSpPr>
+      <p:grpSpPr>
+        <a:xfrm>
+          <a:off x="0" y="0"/>
+          <a:ext cx="0" cy="0"/>
+          <a:chOff x="0" y="0"/>
+          <a:chExt cx="0" cy="0"/>
+        </a:xfrm>
+      </p:grpSpPr>
+      <p:sp>
+        <p:nvSpPr>
+          <p:cNvPr id="2" name="Slide Image Placeholder 1"/>
+          <p:cNvSpPr>
+            <a:spLocks noGrp="1"/>
+          </p:cNvSpPr>
+          <p:nvPr>
+            <p:ph type="sldImg" idx="2"/>
+          </p:nvPr>
+        </p:nvSpPr>
+        <p:spPr/>
+      </p:sp>
+      <p:sp>
+        <p:nvSpPr>
+          <p:cNvPr id="3" name="Notes Placeholder 2"/>
+          <p:cNvSpPr>
+            <a:spLocks noGrp="1"/>
+          </p:cNvSpPr>
+          <p:nvPr>
+            <p:ph type="body" idx="3" sz="quarter"/>
+          </p:nvPr>
+        </p:nvSpPr>
+        <p:spPr/>
+        <p:txBody>
+          <a:bodyPr/>
+          <a:lstStyle/>
+          <a:p>
+            <a:r>
+              <a:t>Cada caja del diagrama tiene su script con nombre y apellido; todo el codigo es publico en github.com/carlosperez100/PLN_SP. Lo que NUNCA se versiona es el dato clinico (texto, modelos entrenados sobre texto): DUA de PhysioNet y proteccion de datos. La bitacora guarda comando y salida de consola de cada corrida. NO leer la tabla — queda para preguntas. (15 segundos y avanzar.)</a:t>
+            </a:r>
+          </a:p>
+        </p:txBody>
+      </p:sp>
+      <p:sp>
+        <p:nvSpPr>
+          <p:cNvPr id="4" name="Slide Number Placeholder 3"/>
+          <p:cNvSpPr>
+            <a:spLocks noGrp="1"/>
+          </p:cNvSpPr>
+          <p:nvPr>
+            <p:ph type="sldNum" idx="5" sz="quarter"/>
+          </p:nvPr>
+        </p:nvSpPr>
+        <p:spPr/>
+      </p:sp>
+    </p:spTree>
+  </p:cSld>
+  <p:clrMapOvr>
+    <a:masterClrMapping/>
+  </p:clrMapOvr>
+</p:notes>
 </file>
 
 <file path=ppt/slideLayouts/slideLayout1.xml><?xml version="1.0" encoding="utf-8"?>
@@ -43012,4 +45252,324 @@
     </a:ext>
   </a:extLst>
 </a:theme>
+</file>
+
+<file path=ppt/theme/theme2.xml><?xml version="1.0" encoding="utf-8"?>
+<a:theme xmlns:a="http://schemas.openxmlformats.org/drawingml/2006/main" name="Office Theme">
+  <a:themeElements>
+    <a:clrScheme name="Office">
+      <a:dk1>
+        <a:sysClr val="windowText" lastClr="000000"/>
+      </a:dk1>
+      <a:lt1>
+        <a:sysClr val="window" lastClr="FFFFFF"/>
+      </a:lt1>
+      <a:dk2>
+        <a:srgbClr val="1F497D"/>
+      </a:dk2>
+      <a:lt2>
+        <a:srgbClr val="EEECE1"/>
+      </a:lt2>
+      <a:accent1>
+        <a:srgbClr val="4F81BD"/>
+      </a:accent1>
+      <a:accent2>
+        <a:srgbClr val="C0504D"/>
+      </a:accent2>
+      <a:accent3>
+        <a:srgbClr val="9BBB59"/>
+      </a:accent3>
+      <a:accent4>
+        <a:srgbClr val="8064A2"/>
+      </a:accent4>
+      <a:accent5>
+        <a:srgbClr val="4BACC6"/>
+      </a:accent5>
+      <a:accent6>
+        <a:srgbClr val="F79646"/>
+      </a:accent6>
+      <a:hlink>
+        <a:srgbClr val="0000FF"/>
+      </a:hlink>
+      <a:folHlink>
+        <a:srgbClr val="800080"/>
+      </a:folHlink>
+    </a:clrScheme>
+    <a:fontScheme name="Office">
+      <a:majorFont>
+        <a:latin typeface="Calibri"/>
+        <a:ea typeface=""/>
+        <a:cs typeface=""/>
+        <a:font script="Jpan" typeface="ＭＳ Ｐゴシック"/>
+        <a:font script="Hang" typeface="맑은 고딕"/>
+        <a:font script="Hans" typeface="宋体"/>
+        <a:font script="Hant" typeface="新細明體"/>
+        <a:font script="Arab" typeface="Times New Roman"/>
+        <a:font script="Hebr" typeface="Times New Roman"/>
+        <a:font script="Thai" typeface="Angsana New"/>
+        <a:font script="Ethi" typeface="Nyala"/>
+        <a:font script="Beng" typeface="Vrinda"/>
+        <a:font script="Gujr" typeface="Shruti"/>
+        <a:font script="Khmr" typeface="MoolBoran"/>
+        <a:font script="Knda" typeface="Tunga"/>
+        <a:font script="Guru" typeface="Raavi"/>
+        <a:font script="Cans" typeface="Euphemia"/>
+        <a:font script="Cher" typeface="Plantagenet Cherokee"/>
+        <a:font script="Yiii" typeface="Microsoft Yi Baiti"/>
+        <a:font script="Tibt" typeface="Microsoft Himalaya"/>
+        <a:font script="Thaa" typeface="MV Boli"/>
+        <a:font script="Deva" typeface="Mangal"/>
+        <a:font script="Telu" typeface="Gautami"/>
+        <a:font script="Taml" typeface="Latha"/>
+        <a:font script="Syrc" typeface="Estrangelo Edessa"/>
+        <a:font script="Orya" typeface="Kalinga"/>
+        <a:font script="Mlym" typeface="Kartika"/>
+        <a:font script="Laoo" typeface="DokChampa"/>
+        <a:font script="Sinh" typeface="Iskoola Pota"/>
+        <a:font script="Mong" typeface="Mongolian Baiti"/>
+        <a:font script="Viet" typeface="Times New Roman"/>
+        <a:font script="Uigh" typeface="Microsoft Uighur"/>
+        <a:font script="Geor" typeface="Sylfaen"/>
+      </a:majorFont>
+      <a:minorFont>
+        <a:latin typeface="Calibri"/>
+        <a:ea typeface=""/>
+        <a:cs typeface=""/>
+        <a:font script="Jpan" typeface="ＭＳ Ｐゴシック"/>
+        <a:font script="Hang" typeface="맑은 고딕"/>
+        <a:font script="Hans" typeface="宋体"/>
+        <a:font script="Hant" typeface="新細明體"/>
+        <a:font script="Arab" typeface="Arial"/>
+        <a:font script="Hebr" typeface="Arial"/>
+        <a:font script="Thai" typeface="Cordia New"/>
+        <a:font script="Ethi" typeface="Nyala"/>
+        <a:font script="Beng" typeface="Vrinda"/>
+        <a:font script="Gujr" typeface="Shruti"/>
+        <a:font script="Khmr" typeface="DaunPenh"/>
+        <a:font script="Knda" typeface="Tunga"/>
+        <a:font script="Guru" typeface="Raavi"/>
+        <a:font script="Cans" typeface="Euphemia"/>
+        <a:font script="Cher" typeface="Plantagenet Cherokee"/>
+        <a:font script="Yiii" typeface="Microsoft Yi Baiti"/>
+        <a:font script="Tibt" typeface="Microsoft Himalaya"/>
+        <a:font script="Thaa" typeface="MV Boli"/>
+        <a:font script="Deva" typeface="Mangal"/>
+        <a:font script="Telu" typeface="Gautami"/>
+        <a:font script="Taml" typeface="Latha"/>
+        <a:font script="Syrc" typeface="Estrangelo Edessa"/>
+        <a:font script="Orya" typeface="Kalinga"/>
+        <a:font script="Mlym" typeface="Kartika"/>
+        <a:font script="Laoo" typeface="DokChampa"/>
+        <a:font script="Sinh" typeface="Iskoola Pota"/>
+        <a:font script="Mong" typeface="Mongolian Baiti"/>
+        <a:font script="Viet" typeface="Arial"/>
+        <a:font script="Uigh" typeface="Microsoft Uighur"/>
+        <a:font script="Geor" typeface="Sylfaen"/>
+      </a:minorFont>
+    </a:fontScheme>
+    <a:fmtScheme name="Office">
+      <a:fillStyleLst>
+        <a:solidFill>
+          <a:schemeClr val="phClr"/>
+        </a:solidFill>
+        <a:gradFill rotWithShape="1">
+          <a:gsLst>
+            <a:gs pos="0">
+              <a:schemeClr val="phClr">
+                <a:tint val="50000"/>
+                <a:satMod val="300000"/>
+              </a:schemeClr>
+            </a:gs>
+            <a:gs pos="35000">
+              <a:schemeClr val="phClr">
+                <a:tint val="37000"/>
+                <a:satMod val="300000"/>
+              </a:schemeClr>
+            </a:gs>
+            <a:gs pos="100000">
+              <a:schemeClr val="phClr">
+                <a:tint val="15000"/>
+                <a:satMod val="350000"/>
+              </a:schemeClr>
+            </a:gs>
+          </a:gsLst>
+          <a:lin ang="16200000" scaled="1"/>
+        </a:gradFill>
+        <a:gradFill rotWithShape="1">
+          <a:gsLst>
+            <a:gs pos="0">
+              <a:schemeClr val="phClr">
+                <a:tint val="100000"/>
+                <a:shade val="100000"/>
+                <a:satMod val="130000"/>
+              </a:schemeClr>
+            </a:gs>
+            <a:gs pos="100000">
+              <a:schemeClr val="phClr">
+                <a:tint val="50000"/>
+                <a:shade val="100000"/>
+                <a:satMod val="350000"/>
+              </a:schemeClr>
+            </a:gs>
+          </a:gsLst>
+          <a:lin ang="16200000" scaled="0"/>
+        </a:gradFill>
+      </a:fillStyleLst>
+      <a:lnStyleLst>
+        <a:ln w="9525" cap="flat" cmpd="sng" algn="ctr">
+          <a:solidFill>
+            <a:schemeClr val="phClr">
+              <a:shade val="95000"/>
+              <a:satMod val="105000"/>
+            </a:schemeClr>
+          </a:solidFill>
+          <a:prstDash val="solid"/>
+        </a:ln>
+        <a:ln w="25400" cap="flat" cmpd="sng" algn="ctr">
+          <a:solidFill>
+            <a:schemeClr val="phClr"/>
+          </a:solidFill>
+          <a:prstDash val="solid"/>
+        </a:ln>
+        <a:ln w="38100" cap="flat" cmpd="sng" algn="ctr">
+          <a:solidFill>
+            <a:schemeClr val="phClr"/>
+          </a:solidFill>
+          <a:prstDash val="solid"/>
+        </a:ln>
+      </a:lnStyleLst>
+      <a:effectStyleLst>
+        <a:effectStyle>
+          <a:effectLst>
+            <a:outerShdw blurRad="40000" dist="20000" dir="5400000" rotWithShape="0">
+              <a:srgbClr val="000000">
+                <a:alpha val="38000"/>
+              </a:srgbClr>
+            </a:outerShdw>
+          </a:effectLst>
+        </a:effectStyle>
+        <a:effectStyle>
+          <a:effectLst>
+            <a:outerShdw blurRad="40000" dist="23000" dir="5400000" rotWithShape="0">
+              <a:srgbClr val="000000">
+                <a:alpha val="35000"/>
+              </a:srgbClr>
+            </a:outerShdw>
+          </a:effectLst>
+        </a:effectStyle>
+        <a:effectStyle>
+          <a:effectLst>
+            <a:outerShdw blurRad="40000" dist="23000" dir="5400000" rotWithShape="0">
+              <a:srgbClr val="000000">
+                <a:alpha val="35000"/>
+              </a:srgbClr>
+            </a:outerShdw>
+          </a:effectLst>
+          <a:scene3d>
+            <a:camera prst="orthographicFront">
+              <a:rot lat="0" lon="0" rev="0"/>
+            </a:camera>
+            <a:lightRig rig="threePt" dir="t">
+              <a:rot lat="0" lon="0" rev="1200000"/>
+            </a:lightRig>
+          </a:scene3d>
+          <a:sp3d>
+            <a:bevelT w="63500" h="25400"/>
+          </a:sp3d>
+        </a:effectStyle>
+      </a:effectStyleLst>
+      <a:bgFillStyleLst>
+        <a:solidFill>
+          <a:schemeClr val="phClr"/>
+        </a:solidFill>
+        <a:gradFill rotWithShape="1">
+          <a:gsLst>
+            <a:gs pos="0">
+              <a:schemeClr val="phClr">
+                <a:tint val="40000"/>
+                <a:satMod val="350000"/>
+              </a:schemeClr>
+            </a:gs>
+            <a:gs pos="40000">
+              <a:schemeClr val="phClr">
+                <a:tint val="45000"/>
+                <a:shade val="99000"/>
+                <a:satMod val="350000"/>
+              </a:schemeClr>
+            </a:gs>
+            <a:gs pos="100000">
+              <a:schemeClr val="phClr">
+                <a:shade val="20000"/>
+                <a:satMod val="255000"/>
+              </a:schemeClr>
+            </a:gs>
+          </a:gsLst>
+          <a:path path="circle">
+            <a:fillToRect l="50000" t="-80000" r="50000" b="180000"/>
+          </a:path>
+        </a:gradFill>
+        <a:gradFill rotWithShape="1">
+          <a:gsLst>
+            <a:gs pos="0">
+              <a:schemeClr val="phClr">
+                <a:tint val="80000"/>
+                <a:satMod val="300000"/>
+              </a:schemeClr>
+            </a:gs>
+            <a:gs pos="100000">
+              <a:schemeClr val="phClr">
+                <a:shade val="30000"/>
+                <a:satMod val="200000"/>
+              </a:schemeClr>
+            </a:gs>
+          </a:gsLst>
+          <a:path path="circle">
+            <a:fillToRect l="50000" t="50000" r="50000" b="50000"/>
+          </a:path>
+        </a:gradFill>
+      </a:bgFillStyleLst>
+    </a:fmtScheme>
+  </a:themeElements>
+  <a:objectDefaults>
+    <a:spDef>
+      <a:spPr/>
+      <a:bodyPr/>
+      <a:lstStyle/>
+      <a:style>
+        <a:lnRef idx="1">
+          <a:schemeClr val="accent1"/>
+        </a:lnRef>
+        <a:fillRef idx="3">
+          <a:schemeClr val="accent1"/>
+        </a:fillRef>
+        <a:effectRef idx="2">
+          <a:schemeClr val="accent1"/>
+        </a:effectRef>
+        <a:fontRef idx="minor">
+          <a:schemeClr val="lt1"/>
+        </a:fontRef>
+      </a:style>
+    </a:spDef>
+    <a:lnDef>
+      <a:spPr/>
+      <a:bodyPr/>
+      <a:lstStyle/>
+      <a:style>
+        <a:lnRef idx="2">
+          <a:schemeClr val="accent1"/>
+        </a:lnRef>
+        <a:fillRef idx="0">
+          <a:schemeClr val="accent1"/>
+        </a:fillRef>
+        <a:effectRef idx="1">
+          <a:schemeClr val="accent1"/>
+        </a:effectRef>
+        <a:fontRef idx="minor">
+          <a:schemeClr val="tx1"/>
+        </a:fontRef>
+      </a:style>
+    </a:lnDef>
+  </a:objectDefaults>
+  <a:extraClrSchemeLst/>
+</a:theme>
 </file>
</xml_diff>

<commit_message>
Presentacion con la institucion anonimizada (referencia reservada), igual que el articulo
</commit_message>
<xml_diff>
--- a/presentacion/Presentacion_Trabajo_Final_PLN_CarlosPerez.pptx
+++ b/presentacion/Presentacion_Trabajo_Final_PLN_CarlosPerez.pptx
@@ -33797,7 +33797,7 @@
                 </a:solidFill>
                 <a:latin typeface="Calibri"/>
               </a:rPr>
-              <a:t>La salida del canal de PLN alimenta la matriz de priorización vigente en EsSalud. Esto ya no es PLN: es el destino del trabajo.</a:t>
+              <a:t>La salida del canal de PLN alimenta la matriz de priorización vigente en la institución. Esto ya no es PLN: es el destino del trabajo.</a:t>
             </a:r>
           </a:p>
         </p:txBody>
@@ -35433,7 +35433,7 @@
                 </a:solidFill>
                 <a:latin typeface="Calibri"/>
               </a:rPr>
-              <a:t>La matriz no es una propuesta del autor: la Directiva N.º 7-OGCyH-ESSALUD-2020 la cita textualmente en su artículo 5.13 como el instrumento vigente.</a:t>
+              <a:t>La matriz no es una propuesta del autor: la Directiva institucional de calidad de 2020 la cita textualmente en su artículo 5.13 como el instrumento vigente.</a:t>
             </a:r>
           </a:p>
         </p:txBody>
@@ -41082,7 +41082,7 @@
                 </a:solidFill>
                 <a:latin typeface="Calibri"/>
               </a:rPr>
-              <a:t>EsSalud. Directiva GG-ESSALUD-2021: registro, notificación y gestión de los ERSP. Anexos 02 y 03.</a:t>
+              <a:t>Institución peruana de salud (ref. reservada). Directiva de 2021: registro, notificación y gestión de los ERSP. Anexos 02 y 03.</a:t>
             </a:r>
           </a:p>
         </p:txBody>
@@ -41683,7 +41683,7 @@
                 </a:solidFill>
                 <a:latin typeface="Calibri"/>
               </a:rPr>
-              <a:t>La Directiva GG-ESSALUD-2021 los regula y define su notificación obligatoria.</a:t>
+              <a:t>La directiva institucional de 2021 los regula y define su notificación obligatoria.</a:t>
             </a:r>
           </a:p>
         </p:txBody>
@@ -44706,7 +44706,7 @@
                 </a:solidFill>
                 <a:latin typeface="Calibri"/>
               </a:rPr>
-              <a:t>de los eventos adversos no se notifican en EsSalud</a:t>
+              <a:t>de los eventos adversos no se notifican en la institución</a:t>
             </a:r>
           </a:p>
         </p:txBody>
@@ -46188,7 +46188,7 @@
                 </a:solidFill>
                 <a:latin typeface="Calibri"/>
               </a:rPr>
-              <a:t>Objetivo general — diseñar, implementar y validar un canal de PLN que detecte y priorice eventos adversos automáticamente, con miras a su transferencia a EsSalud.</a:t>
+              <a:t>Objetivo general — diseñar, implementar y validar un canal de PLN que detecte y priorice eventos adversos automáticamente, con miras a su transferencia a la institución de destino.</a:t>
             </a:r>
           </a:p>
         </p:txBody>

</xml_diff>